<commit_message>
docs(nv5): add traceable demo evidence to final report
</commit_message>
<xml_diff>
--- a/report/deliverables/slides_nhom_tomato_two_models_nv5.pptx
+++ b/report/deliverables/slides_nhom_tomato_two_models_nv5.pptx
@@ -2,24 +2,24 @@
 <file path=ppt/presentation.xml><?xml version="1.0" encoding="utf-8"?>
 <p:presentation xmlns:p="http://schemas.openxmlformats.org/presentationml/2006/main">
   <p:sldMasterIdLst>
-    <p:sldMasterId xmlns:r="http://schemas.openxmlformats.org/officeDocument/2006/relationships" id="2147483648" r:id="Rebf11e1bcde344fa"/>
+    <p:sldMasterId xmlns:r="http://schemas.openxmlformats.org/officeDocument/2006/relationships" id="2147483648" r:id="Rc414eb0efa6b4227"/>
   </p:sldMasterIdLst>
   <p:notesMasterIdLst>
-    <p:notesMasterId xmlns:r="http://schemas.openxmlformats.org/officeDocument/2006/relationships" r:id="Rb1fbcd704f214b72"/>
+    <p:notesMasterId xmlns:r="http://schemas.openxmlformats.org/officeDocument/2006/relationships" r:id="Rc55d3dbcf7114b16"/>
   </p:notesMasterIdLst>
   <p:sldIdLst>
-    <p:sldId xmlns:r="http://schemas.openxmlformats.org/officeDocument/2006/relationships" id="256" r:id="R63a3350a3c7b4b64"/>
-    <p:sldId xmlns:r="http://schemas.openxmlformats.org/officeDocument/2006/relationships" id="257" r:id="Rde3f0a46afbc4559"/>
-    <p:sldId xmlns:r="http://schemas.openxmlformats.org/officeDocument/2006/relationships" id="258" r:id="R2dbdfbf307aa46d1"/>
-    <p:sldId xmlns:r="http://schemas.openxmlformats.org/officeDocument/2006/relationships" id="259" r:id="R8dcb9ff120e14aa9"/>
-    <p:sldId xmlns:r="http://schemas.openxmlformats.org/officeDocument/2006/relationships" id="260" r:id="R60e480841d794368"/>
-    <p:sldId xmlns:r="http://schemas.openxmlformats.org/officeDocument/2006/relationships" id="261" r:id="R47273237a0d34a46"/>
-    <p:sldId xmlns:r="http://schemas.openxmlformats.org/officeDocument/2006/relationships" id="262" r:id="R84af25691e2b49e5"/>
-    <p:sldId xmlns:r="http://schemas.openxmlformats.org/officeDocument/2006/relationships" id="263" r:id="R2738616e7d084e95"/>
-    <p:sldId xmlns:r="http://schemas.openxmlformats.org/officeDocument/2006/relationships" id="264" r:id="R141421cdaf784003"/>
-    <p:sldId xmlns:r="http://schemas.openxmlformats.org/officeDocument/2006/relationships" id="265" r:id="R690343d3121347d5"/>
-    <p:sldId xmlns:r="http://schemas.openxmlformats.org/officeDocument/2006/relationships" id="266" r:id="R3c521324d4a8436a"/>
-    <p:sldId xmlns:r="http://schemas.openxmlformats.org/officeDocument/2006/relationships" id="267" r:id="R50fea7a250b749e0"/>
+    <p:sldId xmlns:r="http://schemas.openxmlformats.org/officeDocument/2006/relationships" id="256" r:id="R3e68854a00ca4383"/>
+    <p:sldId xmlns:r="http://schemas.openxmlformats.org/officeDocument/2006/relationships" id="257" r:id="Rc7d2296298af4c9f"/>
+    <p:sldId xmlns:r="http://schemas.openxmlformats.org/officeDocument/2006/relationships" id="258" r:id="Rcbecac5714f8485d"/>
+    <p:sldId xmlns:r="http://schemas.openxmlformats.org/officeDocument/2006/relationships" id="259" r:id="R4349295d57df4314"/>
+    <p:sldId xmlns:r="http://schemas.openxmlformats.org/officeDocument/2006/relationships" id="260" r:id="R2aa125c4c6324176"/>
+    <p:sldId xmlns:r="http://schemas.openxmlformats.org/officeDocument/2006/relationships" id="261" r:id="R6a4446ce58b44f42"/>
+    <p:sldId xmlns:r="http://schemas.openxmlformats.org/officeDocument/2006/relationships" id="262" r:id="R0184fdf9cb49455e"/>
+    <p:sldId xmlns:r="http://schemas.openxmlformats.org/officeDocument/2006/relationships" id="263" r:id="Ra09e5861b6594ae4"/>
+    <p:sldId xmlns:r="http://schemas.openxmlformats.org/officeDocument/2006/relationships" id="264" r:id="R196314c438184b85"/>
+    <p:sldId xmlns:r="http://schemas.openxmlformats.org/officeDocument/2006/relationships" id="265" r:id="R52d81cb3801949d3"/>
+    <p:sldId xmlns:r="http://schemas.openxmlformats.org/officeDocument/2006/relationships" id="266" r:id="R838bd052d78a44c1"/>
+    <p:sldId xmlns:r="http://schemas.openxmlformats.org/officeDocument/2006/relationships" id="267" r:id="R6736fb9e0d714bfd"/>
   </p:sldIdLst>
   <p:sldSz cx="12192000" cy="6858000"/>
   <p:notesSz cx="6858000" cy="9144000"/>
@@ -1222,7 +1222,7 @@
           <p:cNvPr id="3" name="Title">
             <a:extLst xmlns:a="http://schemas.openxmlformats.org/drawingml/2006/main">
               <a:ext uri="{FF2B5EF4-FFF2-40B4-BE49-F238E27FC236}">
-                <a16:creationId xmlns:a16="http://schemas.microsoft.com/office/drawing/2014/main" id="{D7510E97-FB9C-46C8-9ED3-854FF7358B17}"/>
+                <a16:creationId xmlns:a16="http://schemas.microsoft.com/office/drawing/2014/main" id="{50B583C7-9B02-498C-A60A-6CC678EF6007}"/>
               </a:ext>
             </a:extLst>
           </p:cNvPr>
@@ -1451,7 +1451,7 @@
           <p:cNvPr id="2" name="Subtitle">
             <a:extLst xmlns:a="http://schemas.openxmlformats.org/drawingml/2006/main">
               <a:ext uri="{FF2B5EF4-FFF2-40B4-BE49-F238E27FC236}">
-                <a16:creationId xmlns:a16="http://schemas.microsoft.com/office/drawing/2014/main" id="{B6B5F2F2-0FE7-4043-8947-73BDDF386A7E}"/>
+                <a16:creationId xmlns:a16="http://schemas.microsoft.com/office/drawing/2014/main" id="{48386AA3-3BC9-4AA7-8AEB-D03FD6BBF4E1}"/>
               </a:ext>
             </a:extLst>
           </p:cNvPr>
@@ -1697,7 +1697,7 @@
           <p:cNvPr id="2" name="Section title">
             <a:extLst xmlns:a="http://schemas.openxmlformats.org/drawingml/2006/main">
               <a:ext uri="{FF2B5EF4-FFF2-40B4-BE49-F238E27FC236}">
-                <a16:creationId xmlns:a16="http://schemas.microsoft.com/office/drawing/2014/main" id="{38443694-006A-4609-93C3-714B7CCC208B}"/>
+                <a16:creationId xmlns:a16="http://schemas.microsoft.com/office/drawing/2014/main" id="{AEC9F9E2-4ADD-4C9B-8A49-433AE8E0766E}"/>
               </a:ext>
             </a:extLst>
           </p:cNvPr>
@@ -1943,7 +1943,7 @@
           <p:cNvPr id="3" name="Title">
             <a:extLst xmlns:a="http://schemas.openxmlformats.org/drawingml/2006/main">
               <a:ext uri="{FF2B5EF4-FFF2-40B4-BE49-F238E27FC236}">
-                <a16:creationId xmlns:a16="http://schemas.microsoft.com/office/drawing/2014/main" id="{4E1A3071-AA82-4950-A590-C2B23E290B09}"/>
+                <a16:creationId xmlns:a16="http://schemas.microsoft.com/office/drawing/2014/main" id="{AF6714A8-F6B8-40B7-BC1A-76333E0D6EF1}"/>
               </a:ext>
             </a:extLst>
           </p:cNvPr>
@@ -2172,7 +2172,7 @@
           <p:cNvPr id="2" name="Body">
             <a:extLst xmlns:a="http://schemas.openxmlformats.org/drawingml/2006/main">
               <a:ext uri="{FF2B5EF4-FFF2-40B4-BE49-F238E27FC236}">
-                <a16:creationId xmlns:a16="http://schemas.microsoft.com/office/drawing/2014/main" id="{83427F89-031A-4141-B865-6A894D9FF189}"/>
+                <a16:creationId xmlns:a16="http://schemas.microsoft.com/office/drawing/2014/main" id="{B3D5AC9D-A704-48F1-863F-ADDED3AB62A0}"/>
               </a:ext>
             </a:extLst>
           </p:cNvPr>
@@ -2418,7 +2418,7 @@
           <p:cNvPr id="4" name="Title">
             <a:extLst xmlns:a="http://schemas.openxmlformats.org/drawingml/2006/main">
               <a:ext uri="{FF2B5EF4-FFF2-40B4-BE49-F238E27FC236}">
-                <a16:creationId xmlns:a16="http://schemas.microsoft.com/office/drawing/2014/main" id="{AD66B030-1962-4778-9C49-CAE0B771A16C}"/>
+                <a16:creationId xmlns:a16="http://schemas.microsoft.com/office/drawing/2014/main" id="{8F700272-1DA9-4C87-BAC5-4121F75D03DC}"/>
               </a:ext>
             </a:extLst>
           </p:cNvPr>
@@ -2647,7 +2647,7 @@
           <p:cNvPr id="2" name="Left column">
             <a:extLst xmlns:a="http://schemas.openxmlformats.org/drawingml/2006/main">
               <a:ext uri="{FF2B5EF4-FFF2-40B4-BE49-F238E27FC236}">
-                <a16:creationId xmlns:a16="http://schemas.microsoft.com/office/drawing/2014/main" id="{94DAA124-5C24-4225-8F89-99DEB932CE50}"/>
+                <a16:creationId xmlns:a16="http://schemas.microsoft.com/office/drawing/2014/main" id="{E41781BF-40A1-4B5D-8784-EA61B6A1E93C}"/>
               </a:ext>
             </a:extLst>
           </p:cNvPr>
@@ -2876,7 +2876,7 @@
           <p:cNvPr id="3" name="Right column">
             <a:extLst xmlns:a="http://schemas.openxmlformats.org/drawingml/2006/main">
               <a:ext uri="{FF2B5EF4-FFF2-40B4-BE49-F238E27FC236}">
-                <a16:creationId xmlns:a16="http://schemas.microsoft.com/office/drawing/2014/main" id="{7F1EA195-0AA4-4B1B-B365-6B5D01A8DA3D}"/>
+                <a16:creationId xmlns:a16="http://schemas.microsoft.com/office/drawing/2014/main" id="{66C32416-0AB9-4C18-80CB-8BA621D9009A}"/>
               </a:ext>
             </a:extLst>
           </p:cNvPr>
@@ -3122,7 +3122,7 @@
           <p:cNvPr id="3" name="Title">
             <a:extLst xmlns:a="http://schemas.openxmlformats.org/drawingml/2006/main">
               <a:ext uri="{FF2B5EF4-FFF2-40B4-BE49-F238E27FC236}">
-                <a16:creationId xmlns:a16="http://schemas.microsoft.com/office/drawing/2014/main" id="{5FF9C567-9D48-40D6-A750-733C903936E7}"/>
+                <a16:creationId xmlns:a16="http://schemas.microsoft.com/office/drawing/2014/main" id="{B708D0E9-86ED-48EA-826A-2BBFFB462DD1}"/>
               </a:ext>
             </a:extLst>
           </p:cNvPr>
@@ -3351,7 +3351,7 @@
           <p:cNvPr id="2" name="Left column">
             <a:extLst xmlns:a="http://schemas.openxmlformats.org/drawingml/2006/main">
               <a:ext uri="{FF2B5EF4-FFF2-40B4-BE49-F238E27FC236}">
-                <a16:creationId xmlns:a16="http://schemas.microsoft.com/office/drawing/2014/main" id="{E1D63249-E916-4B43-AEE0-E05D4351938F}"/>
+                <a16:creationId xmlns:a16="http://schemas.microsoft.com/office/drawing/2014/main" id="{FB92325C-7EFB-49C0-9A87-1B66791285A2}"/>
               </a:ext>
             </a:extLst>
           </p:cNvPr>
@@ -3618,12 +3618,12 @@
   </p:cSld>
   <p:clrMap bg1="lt1" tx1="dk1" bg2="lt2" tx2="dk2" accent1="accent1" accent2="accent2" accent3="accent3" accent4="accent4" accent5="accent5" accent6="accent6" hlink="hlink" folHlink="folHlink"/>
   <p:sldLayoutIdLst>
-    <p:sldLayoutId xmlns:r="http://schemas.openxmlformats.org/officeDocument/2006/relationships" id="2147483649" r:id="R370c4827d67d45a6"/>
-    <p:sldLayoutId xmlns:r="http://schemas.openxmlformats.org/officeDocument/2006/relationships" id="2147483650" r:id="Rfd8d6901d5bd4ee7"/>
-    <p:sldLayoutId xmlns:r="http://schemas.openxmlformats.org/officeDocument/2006/relationships" id="2147483651" r:id="R77f052a293bd4902"/>
-    <p:sldLayoutId xmlns:r="http://schemas.openxmlformats.org/officeDocument/2006/relationships" id="2147483652" r:id="R960eb05125664727"/>
-    <p:sldLayoutId xmlns:r="http://schemas.openxmlformats.org/officeDocument/2006/relationships" id="2147483653" r:id="Rac348f29e2a14bb3"/>
-    <p:sldLayoutId xmlns:r="http://schemas.openxmlformats.org/officeDocument/2006/relationships" id="2147483654" r:id="R2ca1d11ce2d44813"/>
+    <p:sldLayoutId xmlns:r="http://schemas.openxmlformats.org/officeDocument/2006/relationships" id="2147483649" r:id="R78a12e8a9c9f4d9f"/>
+    <p:sldLayoutId xmlns:r="http://schemas.openxmlformats.org/officeDocument/2006/relationships" id="2147483650" r:id="Rd1a04272d18741ac"/>
+    <p:sldLayoutId xmlns:r="http://schemas.openxmlformats.org/officeDocument/2006/relationships" id="2147483651" r:id="R17fea3de2d6b45c9"/>
+    <p:sldLayoutId xmlns:r="http://schemas.openxmlformats.org/officeDocument/2006/relationships" id="2147483652" r:id="R1c24a5a3d4854f8c"/>
+    <p:sldLayoutId xmlns:r="http://schemas.openxmlformats.org/officeDocument/2006/relationships" id="2147483653" r:id="Rea697677218b4b20"/>
+    <p:sldLayoutId xmlns:r="http://schemas.openxmlformats.org/officeDocument/2006/relationships" id="2147483654" r:id="R5e26e09318c0482f"/>
   </p:sldLayoutIdLst>
   <p:txStyles>
     <p:titleStyle>
@@ -4150,6 +4150,206 @@
 </a:theme>
 </file>
 
+<file path=ppt/slides/charts/chart1.xml><?xml version="1.0" encoding="utf-8"?>
+<c:chartSpace xmlns:c="http://schemas.openxmlformats.org/drawingml/2006/chart" xmlns:r="http://schemas.openxmlformats.org/officeDocument/2006/relationships">
+  <c:lang val="en-US"/>
+  <c:chart>
+    <c:title>
+      <c:tx>
+        <c:rich>
+          <a:bodyPr xmlns:a="http://schemas.openxmlformats.org/drawingml/2006/main"/>
+          <a:lstStyle xmlns:a="http://schemas.openxmlformats.org/drawingml/2006/main"/>
+          <a:p xmlns:a="http://schemas.openxmlformats.org/drawingml/2006/main">
+            <a:r>
+              <a:rPr sz="1350" b="1">
+                <a:solidFill>
+                  <a:srgbClr val="17202A"/>
+                </a:solidFill>
+              </a:rPr>
+              <a:t>Macro F1 trên Test</a:t>
+            </a:r>
+          </a:p>
+        </c:rich>
+      </c:tx>
+      <c:overlay val="0"/>
+      <c:txPr>
+        <a:bodyPr xmlns:a="http://schemas.openxmlformats.org/drawingml/2006/main" anchorCtr="1"/>
+        <a:lstStyle xmlns:a="http://schemas.openxmlformats.org/drawingml/2006/main"/>
+        <a:p xmlns:a="http://schemas.openxmlformats.org/drawingml/2006/main">
+          <a:pPr>
+            <a:defRPr sz="1350" b="1">
+              <a:solidFill>
+                <a:srgbClr val="17202A"/>
+              </a:solidFill>
+            </a:defRPr>
+          </a:pPr>
+        </a:p>
+      </c:txPr>
+    </c:title>
+    <c:plotArea>
+      <c:barChart>
+        <c:barDir val="col"/>
+        <c:grouping val="clustered"/>
+        <c:varyColors val="0"/>
+        <c:ser>
+          <c:idx val="0"/>
+          <c:order val="0"/>
+          <c:tx>
+            <c:v>Macro F1</c:v>
+          </c:tx>
+          <c:spPr>
+            <a:solidFill xmlns:a="http://schemas.openxmlformats.org/drawingml/2006/main">
+              <a:srgbClr val="2F5597"/>
+            </a:solidFill>
+          </c:spPr>
+          <c:invertIfNegative val="0"/>
+          <c:cat>
+            <c:strRef>
+              <c:f>'Chart Data'!$A$2:$A$3</c:f>
+              <c:strCache>
+                <c:ptCount val="2"/>
+                <c:pt idx="0">
+                  <c:v>CNN</c:v>
+                </c:pt>
+                <c:pt idx="1">
+                  <c:v>ResNet18</c:v>
+                </c:pt>
+              </c:strCache>
+            </c:strRef>
+          </c:cat>
+          <c:val>
+            <c:numRef>
+              <c:f>'Chart Data'!$B$2:$B$3</c:f>
+              <c:numCache>
+                <c:formatCode>0%</c:formatCode>
+                <c:ptCount val="2"/>
+                <c:pt idx="0">
+                  <c:v>0.965</c:v>
+                </c:pt>
+                <c:pt idx="1">
+                  <c:v>0.984</c:v>
+                </c:pt>
+              </c:numCache>
+            </c:numRef>
+          </c:val>
+        </c:ser>
+        <c:dLbls>
+          <c:numFmt formatCode="0.00%" sourceLinked="0"/>
+          <c:txPr>
+            <a:bodyPr xmlns:a="http://schemas.openxmlformats.org/drawingml/2006/main" anchorCtr="1"/>
+            <a:lstStyle xmlns:a="http://schemas.openxmlformats.org/drawingml/2006/main"/>
+            <a:p xmlns:a="http://schemas.openxmlformats.org/drawingml/2006/main">
+              <a:pPr>
+                <a:defRPr sz="975" b="1">
+                  <a:solidFill>
+                    <a:srgbClr val="17202A"/>
+                  </a:solidFill>
+                </a:defRPr>
+              </a:pPr>
+            </a:p>
+          </c:txPr>
+          <c:dLblPos val="outEnd"/>
+          <c:showLegendKey val="0"/>
+          <c:showVal val="1"/>
+          <c:showCatName val="0"/>
+          <c:showSerName val="0"/>
+          <c:showPercent val="0"/>
+          <c:showBubbleSize val="0"/>
+          <c:showLeaderLines val="0"/>
+        </c:dLbls>
+        <c:gapWidth val="70"/>
+        <c:axId val="48650112"/>
+        <c:axId val="48672768"/>
+      </c:barChart>
+      <c:catAx>
+        <c:axId val="48650112"/>
+        <c:scaling>
+          <c:orientation val="minMax"/>
+        </c:scaling>
+        <c:delete val="0"/>
+        <c:axPos val="b"/>
+        <c:numFmt formatCode="General"/>
+        <c:majorTickMark val="none"/>
+        <c:minorTickMark val="none"/>
+        <c:spPr>
+          <a:ln xmlns:a="http://schemas.openxmlformats.org/drawingml/2006/main" w="9525">
+            <a:solidFill>
+              <a:srgbClr val="D9D9D9"/>
+            </a:solidFill>
+            <a:prstDash val="solid"/>
+          </a:ln>
+        </c:spPr>
+        <c:txPr>
+          <a:bodyPr xmlns:a="http://schemas.openxmlformats.org/drawingml/2006/main" anchorCtr="1"/>
+          <a:lstStyle xmlns:a="http://schemas.openxmlformats.org/drawingml/2006/main"/>
+          <a:p xmlns:a="http://schemas.openxmlformats.org/drawingml/2006/main">
+            <a:pPr>
+              <a:defRPr sz="1125">
+                <a:solidFill>
+                  <a:srgbClr val="17202A"/>
+                </a:solidFill>
+              </a:defRPr>
+            </a:pPr>
+          </a:p>
+        </c:txPr>
+        <c:crossAx val="48672768"/>
+      </c:catAx>
+      <c:valAx>
+        <c:axId val="48672768"/>
+        <c:scaling>
+          <c:orientation val="minMax"/>
+          <c:max val="1"/>
+          <c:min val="0.94"/>
+        </c:scaling>
+        <c:delete val="0"/>
+        <c:axPos val="l"/>
+        <c:majorGridlines>
+          <c:spPr>
+            <a:ln xmlns:a="http://schemas.openxmlformats.org/drawingml/2006/main" w="9525">
+              <a:solidFill>
+                <a:srgbClr val="D9D9D9"/>
+              </a:solidFill>
+              <a:prstDash val="solid"/>
+            </a:ln>
+          </c:spPr>
+        </c:majorGridlines>
+        <c:numFmt formatCode="0%"/>
+        <c:majorTickMark val="none"/>
+        <c:minorTickMark val="none"/>
+        <c:spPr>
+          <a:ln xmlns:a="http://schemas.openxmlformats.org/drawingml/2006/main" w="9525">
+            <a:solidFill>
+              <a:srgbClr val="D4D4D4"/>
+            </a:solidFill>
+            <a:prstDash val="solid"/>
+          </a:ln>
+        </c:spPr>
+        <c:txPr>
+          <a:bodyPr xmlns:a="http://schemas.openxmlformats.org/drawingml/2006/main" anchorCtr="1"/>
+          <a:lstStyle xmlns:a="http://schemas.openxmlformats.org/drawingml/2006/main"/>
+          <a:p xmlns:a="http://schemas.openxmlformats.org/drawingml/2006/main">
+            <a:pPr>
+              <a:defRPr sz="900">
+                <a:solidFill>
+                  <a:srgbClr val="5B6573"/>
+                </a:solidFill>
+              </a:defRPr>
+            </a:pPr>
+          </a:p>
+        </c:txPr>
+        <c:crossAx val="48650112"/>
+        <c:crossBetween val="between"/>
+        <c:majorUnit val="0.02"/>
+      </c:valAx>
+    </c:plotArea>
+    <c:plotVisOnly val="1"/>
+  </c:chart>
+  <c:externalData r:id="rIdChartSnapshot1">
+    <c:autoUpdate val="0"/>
+  </c:externalData>
+</c:chartSpace>
+</file>
+
 <file path=ppt/slides/slide1.xml><?xml version="1.0" encoding="utf-8"?>
 <p:sld xmlns:p="http://schemas.openxmlformats.org/presentationml/2006/main">
   <p:cSld>
@@ -4174,7 +4374,7 @@
           <p:cNvPr id="5" name="">
             <a:extLst xmlns:a="http://schemas.openxmlformats.org/drawingml/2006/main">
               <a:ext uri="{FF2B5EF4-FFF2-40B4-BE49-F238E27FC236}">
-                <a16:creationId xmlns:a16="http://schemas.microsoft.com/office/drawing/2014/main" id="{8CC14320-5032-41FF-8800-02AFFFB75B10}"/>
+                <a16:creationId xmlns:a16="http://schemas.microsoft.com/office/drawing/2014/main" id="{23FD31A2-BEEE-4692-878B-89A53754E3F7}"/>
               </a:ext>
             </a:extLst>
           </p:cNvPr>
@@ -4295,7 +4495,7 @@
           <p:cNvPr id="2" name="">
             <a:extLst xmlns:a="http://schemas.openxmlformats.org/drawingml/2006/main">
               <a:ext uri="{FF2B5EF4-FFF2-40B4-BE49-F238E27FC236}">
-                <a16:creationId xmlns:a16="http://schemas.microsoft.com/office/drawing/2014/main" id="{659267C2-F2D9-4BBF-8241-70A161FCA2C9}"/>
+                <a16:creationId xmlns:a16="http://schemas.microsoft.com/office/drawing/2014/main" id="{F53A4CDC-293D-4C80-9612-E377F511761B}"/>
               </a:ext>
             </a:extLst>
           </p:cNvPr>
@@ -4416,7 +4616,7 @@
           <p:cNvPr id="3" name="">
             <a:extLst xmlns:a="http://schemas.openxmlformats.org/drawingml/2006/main">
               <a:ext uri="{FF2B5EF4-FFF2-40B4-BE49-F238E27FC236}">
-                <a16:creationId xmlns:a16="http://schemas.microsoft.com/office/drawing/2014/main" id="{20680C73-8F9F-440A-842D-B46C672551A6}"/>
+                <a16:creationId xmlns:a16="http://schemas.microsoft.com/office/drawing/2014/main" id="{4349FE79-25C3-4684-8452-164607614E29}"/>
               </a:ext>
             </a:extLst>
           </p:cNvPr>
@@ -4537,7 +4737,7 @@
           <p:cNvPr id="4" name="">
             <a:extLst xmlns:a="http://schemas.openxmlformats.org/drawingml/2006/main">
               <a:ext uri="{FF2B5EF4-FFF2-40B4-BE49-F238E27FC236}">
-                <a16:creationId xmlns:a16="http://schemas.microsoft.com/office/drawing/2014/main" id="{ABED9D48-E694-4B58-A44D-DE1E99C1F6DA}"/>
+                <a16:creationId xmlns:a16="http://schemas.microsoft.com/office/drawing/2014/main" id="{31E74960-1390-4B3B-B2E1-C2B75B58178D}"/>
               </a:ext>
             </a:extLst>
           </p:cNvPr>
@@ -4656,7 +4856,7 @@
     </p:spTree>
     <p:extLst>
       <p:ext uri="{BB962C8B-B14F-4D97-AF65-F5344CB8AC3E}">
-        <p14:creationId xmlns:p14="http://schemas.microsoft.com/office/powerpoint/2010/main" val="1649149122"/>
+        <p14:creationId xmlns:p14="http://schemas.microsoft.com/office/powerpoint/2010/main" val="1092583551"/>
       </p:ext>
     </p:extLst>
   </p:cSld>
@@ -4687,7 +4887,7 @@
           <p:cNvPr id="8" name="">
             <a:extLst xmlns:a="http://schemas.openxmlformats.org/drawingml/2006/main">
               <a:ext uri="{FF2B5EF4-FFF2-40B4-BE49-F238E27FC236}">
-                <a16:creationId xmlns:a16="http://schemas.microsoft.com/office/drawing/2014/main" id="{1A3113F5-1DE5-4CAD-84C0-838289DC50C1}"/>
+                <a16:creationId xmlns:a16="http://schemas.microsoft.com/office/drawing/2014/main" id="{1FF3688F-B01C-40F5-8408-2BDBA4D5040B}"/>
               </a:ext>
             </a:extLst>
           </p:cNvPr>
@@ -4808,7 +5008,7 @@
           <p:cNvPr id="2" name="">
             <a:extLst xmlns:a="http://schemas.openxmlformats.org/drawingml/2006/main">
               <a:ext uri="{FF2B5EF4-FFF2-40B4-BE49-F238E27FC236}">
-                <a16:creationId xmlns:a16="http://schemas.microsoft.com/office/drawing/2014/main" id="{683636CB-5193-4106-A769-8BECD69A7330}"/>
+                <a16:creationId xmlns:a16="http://schemas.microsoft.com/office/drawing/2014/main" id="{0B737ADF-BD33-42AE-B9C0-87912A40372F}"/>
               </a:ext>
             </a:extLst>
           </p:cNvPr>
@@ -4929,7 +5129,7 @@
           <p:cNvPr id="3" name="">
             <a:extLst xmlns:a="http://schemas.openxmlformats.org/drawingml/2006/main">
               <a:ext uri="{FF2B5EF4-FFF2-40B4-BE49-F238E27FC236}">
-                <a16:creationId xmlns:a16="http://schemas.microsoft.com/office/drawing/2014/main" id="{263942B5-9F4A-4CD8-8E45-C17B27879843}"/>
+                <a16:creationId xmlns:a16="http://schemas.microsoft.com/office/drawing/2014/main" id="{B4487A39-C249-427B-8029-C74AEDD99910}"/>
               </a:ext>
             </a:extLst>
           </p:cNvPr>
@@ -5050,7 +5250,7 @@
           <p:cNvPr id="4" name="">
             <a:extLst xmlns:a="http://schemas.openxmlformats.org/drawingml/2006/main">
               <a:ext uri="{FF2B5EF4-FFF2-40B4-BE49-F238E27FC236}">
-                <a16:creationId xmlns:a16="http://schemas.microsoft.com/office/drawing/2014/main" id="{2FF66F2C-ECEE-4006-9394-77FABA173D73}"/>
+                <a16:creationId xmlns:a16="http://schemas.microsoft.com/office/drawing/2014/main" id="{1C9C8514-EDE3-42E8-BA11-688530C16BDA}"/>
               </a:ext>
             </a:extLst>
           </p:cNvPr>
@@ -5239,7 +5439,7 @@
           <p:cNvPr id="5" name="">
             <a:extLst xmlns:a="http://schemas.openxmlformats.org/drawingml/2006/main">
               <a:ext uri="{FF2B5EF4-FFF2-40B4-BE49-F238E27FC236}">
-                <a16:creationId xmlns:a16="http://schemas.microsoft.com/office/drawing/2014/main" id="{E1E8E6F3-C8F0-4FC2-91D0-B8E71D942332}"/>
+                <a16:creationId xmlns:a16="http://schemas.microsoft.com/office/drawing/2014/main" id="{A0DDB509-BDDC-45D6-88C2-D9A147E64EB9}"/>
               </a:ext>
             </a:extLst>
           </p:cNvPr>
@@ -5428,7 +5628,7 @@
           <p:cNvPr id="6" name="">
             <a:extLst xmlns:a="http://schemas.openxmlformats.org/drawingml/2006/main">
               <a:ext uri="{FF2B5EF4-FFF2-40B4-BE49-F238E27FC236}">
-                <a16:creationId xmlns:a16="http://schemas.microsoft.com/office/drawing/2014/main" id="{57FE1873-07D7-4A93-9667-267F3E33725C}"/>
+                <a16:creationId xmlns:a16="http://schemas.microsoft.com/office/drawing/2014/main" id="{59460B28-65E7-457F-82FF-9371784E93FB}"/>
               </a:ext>
             </a:extLst>
           </p:cNvPr>
@@ -5549,7 +5749,7 @@
           <p:cNvPr id="7" name="">
             <a:extLst xmlns:a="http://schemas.openxmlformats.org/drawingml/2006/main">
               <a:ext uri="{FF2B5EF4-FFF2-40B4-BE49-F238E27FC236}">
-                <a16:creationId xmlns:a16="http://schemas.microsoft.com/office/drawing/2014/main" id="{126EA017-2AD2-4643-ACCD-B6CB1E4BEBFE}"/>
+                <a16:creationId xmlns:a16="http://schemas.microsoft.com/office/drawing/2014/main" id="{4EFB63FE-C511-4EE9-98B0-088FE6706E89}"/>
               </a:ext>
             </a:extLst>
           </p:cNvPr>
@@ -5668,7 +5868,7 @@
     </p:spTree>
     <p:extLst>
       <p:ext uri="{BB962C8B-B14F-4D97-AF65-F5344CB8AC3E}">
-        <p14:creationId xmlns:p14="http://schemas.microsoft.com/office/powerpoint/2010/main" val="1381834732"/>
+        <p14:creationId xmlns:p14="http://schemas.microsoft.com/office/powerpoint/2010/main" val="1404986681"/>
       </p:ext>
     </p:extLst>
   </p:cSld>
@@ -5699,7 +5899,7 @@
           <p:cNvPr id="9" name="">
             <a:extLst xmlns:a="http://schemas.openxmlformats.org/drawingml/2006/main">
               <a:ext uri="{FF2B5EF4-FFF2-40B4-BE49-F238E27FC236}">
-                <a16:creationId xmlns:a16="http://schemas.microsoft.com/office/drawing/2014/main" id="{9B455C23-F32A-4B34-9C51-71C47DD0EAF4}"/>
+                <a16:creationId xmlns:a16="http://schemas.microsoft.com/office/drawing/2014/main" id="{9170556A-BE10-46DB-B7BC-2E9E847E97E5}"/>
               </a:ext>
             </a:extLst>
           </p:cNvPr>
@@ -5820,7 +6020,7 @@
           <p:cNvPr id="2" name="">
             <a:extLst xmlns:a="http://schemas.openxmlformats.org/drawingml/2006/main">
               <a:ext uri="{FF2B5EF4-FFF2-40B4-BE49-F238E27FC236}">
-                <a16:creationId xmlns:a16="http://schemas.microsoft.com/office/drawing/2014/main" id="{2BB508B6-76E7-4BB9-BF15-510EC7B4EF77}"/>
+                <a16:creationId xmlns:a16="http://schemas.microsoft.com/office/drawing/2014/main" id="{DCF53015-8EEC-4CB8-B14F-B000EABC6C48}"/>
               </a:ext>
             </a:extLst>
           </p:cNvPr>
@@ -5941,7 +6141,7 @@
           <p:cNvPr id="3" name="">
             <a:extLst xmlns:a="http://schemas.openxmlformats.org/drawingml/2006/main">
               <a:ext uri="{FF2B5EF4-FFF2-40B4-BE49-F238E27FC236}">
-                <a16:creationId xmlns:a16="http://schemas.microsoft.com/office/drawing/2014/main" id="{016E8B6C-FA41-4202-91C3-3B1115EFD719}"/>
+                <a16:creationId xmlns:a16="http://schemas.microsoft.com/office/drawing/2014/main" id="{A1725147-6672-4CD8-81EF-4013B7AAAA79}"/>
               </a:ext>
             </a:extLst>
           </p:cNvPr>
@@ -6062,7 +6262,7 @@
           <p:cNvPr id="4" name="">
             <a:extLst xmlns:a="http://schemas.openxmlformats.org/drawingml/2006/main">
               <a:ext uri="{FF2B5EF4-FFF2-40B4-BE49-F238E27FC236}">
-                <a16:creationId xmlns:a16="http://schemas.microsoft.com/office/drawing/2014/main" id="{0ECE8835-EB69-44BB-84FE-C3C9066C3D56}"/>
+                <a16:creationId xmlns:a16="http://schemas.microsoft.com/office/drawing/2014/main" id="{1AEB9410-6049-4A97-A688-362C30AA260A}"/>
               </a:ext>
             </a:extLst>
           </p:cNvPr>
@@ -6183,7 +6383,7 @@
           <p:cNvPr id="5" name="">
             <a:extLst xmlns:a="http://schemas.openxmlformats.org/drawingml/2006/main">
               <a:ext uri="{FF2B5EF4-FFF2-40B4-BE49-F238E27FC236}">
-                <a16:creationId xmlns:a16="http://schemas.microsoft.com/office/drawing/2014/main" id="{D2B76642-165B-4260-A77E-591468B6F30D}"/>
+                <a16:creationId xmlns:a16="http://schemas.microsoft.com/office/drawing/2014/main" id="{4325115C-E90E-4FFB-89D1-0A375AEC4B99}"/>
               </a:ext>
             </a:extLst>
           </p:cNvPr>
@@ -6338,7 +6538,7 @@
           <p:cNvPr id="6" name="">
             <a:extLst xmlns:a="http://schemas.openxmlformats.org/drawingml/2006/main">
               <a:ext uri="{FF2B5EF4-FFF2-40B4-BE49-F238E27FC236}">
-                <a16:creationId xmlns:a16="http://schemas.microsoft.com/office/drawing/2014/main" id="{2E19583B-C293-4A6F-986F-C8D740FF752D}"/>
+                <a16:creationId xmlns:a16="http://schemas.microsoft.com/office/drawing/2014/main" id="{68B15833-626F-4513-983E-B55CB53C9A9F}"/>
               </a:ext>
             </a:extLst>
           </p:cNvPr>
@@ -6459,7 +6659,7 @@
           <p:cNvPr id="7" name="">
             <a:extLst xmlns:a="http://schemas.openxmlformats.org/drawingml/2006/main">
               <a:ext uri="{FF2B5EF4-FFF2-40B4-BE49-F238E27FC236}">
-                <a16:creationId xmlns:a16="http://schemas.microsoft.com/office/drawing/2014/main" id="{A5F418EF-5F01-40BC-8B38-ED3DE3D1DE05}"/>
+                <a16:creationId xmlns:a16="http://schemas.microsoft.com/office/drawing/2014/main" id="{240E830A-A97B-4352-A396-B5348DF5D6F8}"/>
               </a:ext>
             </a:extLst>
           </p:cNvPr>
@@ -6614,7 +6814,7 @@
           <p:cNvPr id="8" name="">
             <a:extLst xmlns:a="http://schemas.openxmlformats.org/drawingml/2006/main">
               <a:ext uri="{FF2B5EF4-FFF2-40B4-BE49-F238E27FC236}">
-                <a16:creationId xmlns:a16="http://schemas.microsoft.com/office/drawing/2014/main" id="{74570AD4-3BE4-41F1-910F-D98BF80EDE46}"/>
+                <a16:creationId xmlns:a16="http://schemas.microsoft.com/office/drawing/2014/main" id="{06728280-3CE7-4F99-ACA9-EAEBBDC623D1}"/>
               </a:ext>
             </a:extLst>
           </p:cNvPr>
@@ -6733,7 +6933,7 @@
     </p:spTree>
     <p:extLst>
       <p:ext uri="{BB962C8B-B14F-4D97-AF65-F5344CB8AC3E}">
-        <p14:creationId xmlns:p14="http://schemas.microsoft.com/office/powerpoint/2010/main" val="192740015"/>
+        <p14:creationId xmlns:p14="http://schemas.microsoft.com/office/powerpoint/2010/main" val="1437790838"/>
       </p:ext>
     </p:extLst>
   </p:cSld>
@@ -6764,7 +6964,7 @@
           <p:cNvPr id="9" name="">
             <a:extLst xmlns:a="http://schemas.openxmlformats.org/drawingml/2006/main">
               <a:ext uri="{FF2B5EF4-FFF2-40B4-BE49-F238E27FC236}">
-                <a16:creationId xmlns:a16="http://schemas.microsoft.com/office/drawing/2014/main" id="{2D5B1840-D63D-4010-9A8C-618EC8219E2E}"/>
+                <a16:creationId xmlns:a16="http://schemas.microsoft.com/office/drawing/2014/main" id="{EE5EC159-B91A-4972-A31E-8270FABA3335}"/>
               </a:ext>
             </a:extLst>
           </p:cNvPr>
@@ -6885,7 +7085,7 @@
           <p:cNvPr id="2" name="">
             <a:extLst xmlns:a="http://schemas.openxmlformats.org/drawingml/2006/main">
               <a:ext uri="{FF2B5EF4-FFF2-40B4-BE49-F238E27FC236}">
-                <a16:creationId xmlns:a16="http://schemas.microsoft.com/office/drawing/2014/main" id="{EE3ACA2D-AF87-4FF1-AC3F-D390EF3E5C90}"/>
+                <a16:creationId xmlns:a16="http://schemas.microsoft.com/office/drawing/2014/main" id="{3EA9B02C-28B2-4EC0-B619-C654C9EB181F}"/>
               </a:ext>
             </a:extLst>
           </p:cNvPr>
@@ -7006,7 +7206,7 @@
           <p:cNvPr id="3" name="">
             <a:extLst xmlns:a="http://schemas.openxmlformats.org/drawingml/2006/main">
               <a:ext uri="{FF2B5EF4-FFF2-40B4-BE49-F238E27FC236}">
-                <a16:creationId xmlns:a16="http://schemas.microsoft.com/office/drawing/2014/main" id="{CACBDC38-D7D2-417B-868B-6A38295C1605}"/>
+                <a16:creationId xmlns:a16="http://schemas.microsoft.com/office/drawing/2014/main" id="{FFF9259F-9B4B-4EA3-8C3C-8986ABD79D2F}"/>
               </a:ext>
             </a:extLst>
           </p:cNvPr>
@@ -7127,7 +7327,7 @@
           <p:cNvPr id="4" name="">
             <a:extLst xmlns:a="http://schemas.openxmlformats.org/drawingml/2006/main">
               <a:ext uri="{FF2B5EF4-FFF2-40B4-BE49-F238E27FC236}">
-                <a16:creationId xmlns:a16="http://schemas.microsoft.com/office/drawing/2014/main" id="{673159FB-CD1A-4867-A37A-EE5FB9EC73AC}"/>
+                <a16:creationId xmlns:a16="http://schemas.microsoft.com/office/drawing/2014/main" id="{B4D6678A-4291-4620-AA42-E4B730770B98}"/>
               </a:ext>
             </a:extLst>
           </p:cNvPr>
@@ -7248,7 +7448,7 @@
           <p:cNvPr id="5" name="">
             <a:extLst xmlns:a="http://schemas.openxmlformats.org/drawingml/2006/main">
               <a:ext uri="{FF2B5EF4-FFF2-40B4-BE49-F238E27FC236}">
-                <a16:creationId xmlns:a16="http://schemas.microsoft.com/office/drawing/2014/main" id="{05E33996-CCF4-4A16-AD47-8DD63BC0CD5C}"/>
+                <a16:creationId xmlns:a16="http://schemas.microsoft.com/office/drawing/2014/main" id="{971B19DE-3597-4AF8-A34E-8591171948BA}"/>
               </a:ext>
             </a:extLst>
           </p:cNvPr>
@@ -7403,7 +7603,7 @@
           <p:cNvPr id="6" name="">
             <a:extLst xmlns:a="http://schemas.openxmlformats.org/drawingml/2006/main">
               <a:ext uri="{FF2B5EF4-FFF2-40B4-BE49-F238E27FC236}">
-                <a16:creationId xmlns:a16="http://schemas.microsoft.com/office/drawing/2014/main" id="{945AAF9E-AC57-44F2-A73A-459B6BD16581}"/>
+                <a16:creationId xmlns:a16="http://schemas.microsoft.com/office/drawing/2014/main" id="{15AFB7E4-B0E8-434C-9ED8-193DEE9D2FB6}"/>
               </a:ext>
             </a:extLst>
           </p:cNvPr>
@@ -7524,7 +7724,7 @@
           <p:cNvPr id="7" name="">
             <a:extLst xmlns:a="http://schemas.openxmlformats.org/drawingml/2006/main">
               <a:ext uri="{FF2B5EF4-FFF2-40B4-BE49-F238E27FC236}">
-                <a16:creationId xmlns:a16="http://schemas.microsoft.com/office/drawing/2014/main" id="{43061350-5B8F-45B9-B168-05BE59C56C30}"/>
+                <a16:creationId xmlns:a16="http://schemas.microsoft.com/office/drawing/2014/main" id="{A4065E06-799C-4B5A-AD2D-1CFBF0E43B96}"/>
               </a:ext>
             </a:extLst>
           </p:cNvPr>
@@ -7679,7 +7879,7 @@
           <p:cNvPr id="8" name="">
             <a:extLst xmlns:a="http://schemas.openxmlformats.org/drawingml/2006/main">
               <a:ext uri="{FF2B5EF4-FFF2-40B4-BE49-F238E27FC236}">
-                <a16:creationId xmlns:a16="http://schemas.microsoft.com/office/drawing/2014/main" id="{E073AA94-4B54-473F-BFF7-0B9538C89547}"/>
+                <a16:creationId xmlns:a16="http://schemas.microsoft.com/office/drawing/2014/main" id="{DDFF2845-0E3C-44F2-B1E8-092A1B5640AE}"/>
               </a:ext>
             </a:extLst>
           </p:cNvPr>
@@ -7798,7 +7998,7 @@
     </p:spTree>
     <p:extLst>
       <p:ext uri="{BB962C8B-B14F-4D97-AF65-F5344CB8AC3E}">
-        <p14:creationId xmlns:p14="http://schemas.microsoft.com/office/powerpoint/2010/main" val="153636768"/>
+        <p14:creationId xmlns:p14="http://schemas.microsoft.com/office/powerpoint/2010/main" val="1927323880"/>
       </p:ext>
     </p:extLst>
   </p:cSld>
@@ -7829,7 +8029,7 @@
           <p:cNvPr id="8" name="">
             <a:extLst xmlns:a="http://schemas.openxmlformats.org/drawingml/2006/main">
               <a:ext uri="{FF2B5EF4-FFF2-40B4-BE49-F238E27FC236}">
-                <a16:creationId xmlns:a16="http://schemas.microsoft.com/office/drawing/2014/main" id="{3109A43D-CD44-4D74-812D-D27C06CCBC34}"/>
+                <a16:creationId xmlns:a16="http://schemas.microsoft.com/office/drawing/2014/main" id="{BA835B40-4C8C-439D-B2AE-6D81B50E0ED9}"/>
               </a:ext>
             </a:extLst>
           </p:cNvPr>
@@ -7950,7 +8150,7 @@
           <p:cNvPr id="2" name="">
             <a:extLst xmlns:a="http://schemas.openxmlformats.org/drawingml/2006/main">
               <a:ext uri="{FF2B5EF4-FFF2-40B4-BE49-F238E27FC236}">
-                <a16:creationId xmlns:a16="http://schemas.microsoft.com/office/drawing/2014/main" id="{D164EC6A-2254-4FE5-AA14-618A7D44C0F7}"/>
+                <a16:creationId xmlns:a16="http://schemas.microsoft.com/office/drawing/2014/main" id="{B4273726-AC2E-4493-87CB-50A12937D735}"/>
               </a:ext>
             </a:extLst>
           </p:cNvPr>
@@ -8071,7 +8271,7 @@
           <p:cNvPr id="3" name="">
             <a:extLst xmlns:a="http://schemas.openxmlformats.org/drawingml/2006/main">
               <a:ext uri="{FF2B5EF4-FFF2-40B4-BE49-F238E27FC236}">
-                <a16:creationId xmlns:a16="http://schemas.microsoft.com/office/drawing/2014/main" id="{B2B1A476-59E2-4A4D-8A87-C7949F0497B0}"/>
+                <a16:creationId xmlns:a16="http://schemas.microsoft.com/office/drawing/2014/main" id="{2D363255-E1BD-4DD4-8163-7349987528F4}"/>
               </a:ext>
             </a:extLst>
           </p:cNvPr>
@@ -8192,7 +8392,7 @@
           <p:cNvPr id="4" name="">
             <a:extLst xmlns:a="http://schemas.openxmlformats.org/drawingml/2006/main">
               <a:ext uri="{FF2B5EF4-FFF2-40B4-BE49-F238E27FC236}">
-                <a16:creationId xmlns:a16="http://schemas.microsoft.com/office/drawing/2014/main" id="{9765C286-0A0B-468D-A0C3-0E4F1F567E0C}"/>
+                <a16:creationId xmlns:a16="http://schemas.microsoft.com/office/drawing/2014/main" id="{827FC297-5763-4E60-9656-3D588C662BF5}"/>
               </a:ext>
             </a:extLst>
           </p:cNvPr>
@@ -8313,7 +8513,7 @@
           <p:cNvPr id="5" name="">
             <a:extLst xmlns:a="http://schemas.openxmlformats.org/drawingml/2006/main">
               <a:ext uri="{FF2B5EF4-FFF2-40B4-BE49-F238E27FC236}">
-                <a16:creationId xmlns:a16="http://schemas.microsoft.com/office/drawing/2014/main" id="{7B46CF18-E52C-4242-8204-95E3FAE2BDA9}"/>
+                <a16:creationId xmlns:a16="http://schemas.microsoft.com/office/drawing/2014/main" id="{773EA96E-64AD-4967-B642-90EA5CA8E6E3}"/>
               </a:ext>
             </a:extLst>
           </p:cNvPr>
@@ -8468,7 +8668,7 @@
           <p:cNvPr id="6" name="">
             <a:extLst xmlns:a="http://schemas.openxmlformats.org/drawingml/2006/main">
               <a:ext uri="{FF2B5EF4-FFF2-40B4-BE49-F238E27FC236}">
-                <a16:creationId xmlns:a16="http://schemas.microsoft.com/office/drawing/2014/main" id="{D6AAAE6D-25D3-4B6C-91DE-FB0FCBD6800A}"/>
+                <a16:creationId xmlns:a16="http://schemas.microsoft.com/office/drawing/2014/main" id="{7431FCB7-240E-462A-A795-252E2E80F9E4}"/>
               </a:ext>
             </a:extLst>
           </p:cNvPr>
@@ -8589,7 +8789,7 @@
           <p:cNvPr id="7" name="">
             <a:extLst xmlns:a="http://schemas.openxmlformats.org/drawingml/2006/main">
               <a:ext uri="{FF2B5EF4-FFF2-40B4-BE49-F238E27FC236}">
-                <a16:creationId xmlns:a16="http://schemas.microsoft.com/office/drawing/2014/main" id="{4C54E7B3-7383-4DD6-94C3-F64EA5C7624E}"/>
+                <a16:creationId xmlns:a16="http://schemas.microsoft.com/office/drawing/2014/main" id="{7C6E0788-4ED7-4AA9-ADA8-F362E9CA15E2}"/>
               </a:ext>
             </a:extLst>
           </p:cNvPr>
@@ -8742,7 +8942,7 @@
     </p:spTree>
     <p:extLst>
       <p:ext uri="{BB962C8B-B14F-4D97-AF65-F5344CB8AC3E}">
-        <p14:creationId xmlns:p14="http://schemas.microsoft.com/office/powerpoint/2010/main" val="58830642"/>
+        <p14:creationId xmlns:p14="http://schemas.microsoft.com/office/powerpoint/2010/main" val="340170107"/>
       </p:ext>
     </p:extLst>
   </p:cSld>
@@ -8773,7 +8973,7 @@
           <p:cNvPr id="9" name="">
             <a:extLst xmlns:a="http://schemas.openxmlformats.org/drawingml/2006/main">
               <a:ext uri="{FF2B5EF4-FFF2-40B4-BE49-F238E27FC236}">
-                <a16:creationId xmlns:a16="http://schemas.microsoft.com/office/drawing/2014/main" id="{BEF69A36-6097-49DC-B1E9-C3C428614083}"/>
+                <a16:creationId xmlns:a16="http://schemas.microsoft.com/office/drawing/2014/main" id="{B220BCEB-1920-4E3B-9CCD-FA8E866D9239}"/>
               </a:ext>
             </a:extLst>
           </p:cNvPr>
@@ -8894,7 +9094,7 @@
           <p:cNvPr id="2" name="">
             <a:extLst xmlns:a="http://schemas.openxmlformats.org/drawingml/2006/main">
               <a:ext uri="{FF2B5EF4-FFF2-40B4-BE49-F238E27FC236}">
-                <a16:creationId xmlns:a16="http://schemas.microsoft.com/office/drawing/2014/main" id="{042DDC06-C904-42CC-8072-37AB8C4806A8}"/>
+                <a16:creationId xmlns:a16="http://schemas.microsoft.com/office/drawing/2014/main" id="{B5CAAEC4-CB4C-4C6C-B577-905EA3AAB089}"/>
               </a:ext>
             </a:extLst>
           </p:cNvPr>
@@ -9015,7 +9215,7 @@
           <p:cNvPr id="3" name="">
             <a:extLst xmlns:a="http://schemas.openxmlformats.org/drawingml/2006/main">
               <a:ext uri="{FF2B5EF4-FFF2-40B4-BE49-F238E27FC236}">
-                <a16:creationId xmlns:a16="http://schemas.microsoft.com/office/drawing/2014/main" id="{8FE20FCE-07A7-44CD-A9C3-E54E9864A46F}"/>
+                <a16:creationId xmlns:a16="http://schemas.microsoft.com/office/drawing/2014/main" id="{F96088A0-60F8-46EC-ABEB-7632EA9C261E}"/>
               </a:ext>
             </a:extLst>
           </p:cNvPr>
@@ -9136,7 +9336,7 @@
           <p:cNvPr id="4" name="">
             <a:extLst xmlns:a="http://schemas.openxmlformats.org/drawingml/2006/main">
               <a:ext uri="{FF2B5EF4-FFF2-40B4-BE49-F238E27FC236}">
-                <a16:creationId xmlns:a16="http://schemas.microsoft.com/office/drawing/2014/main" id="{AAF7115E-6345-4FA6-8D19-B8939EBCB0D8}"/>
+                <a16:creationId xmlns:a16="http://schemas.microsoft.com/office/drawing/2014/main" id="{8971D521-7992-4410-BC7C-3FE6DE49FBB2}"/>
               </a:ext>
             </a:extLst>
           </p:cNvPr>
@@ -9257,7 +9457,7 @@
           <p:cNvPr id="5" name="">
             <a:extLst xmlns:a="http://schemas.openxmlformats.org/drawingml/2006/main">
               <a:ext uri="{FF2B5EF4-FFF2-40B4-BE49-F238E27FC236}">
-                <a16:creationId xmlns:a16="http://schemas.microsoft.com/office/drawing/2014/main" id="{9CD4AD57-EC29-4874-A453-C835706B0A09}"/>
+                <a16:creationId xmlns:a16="http://schemas.microsoft.com/office/drawing/2014/main" id="{C6C34A34-434A-4B56-81D7-F72BBD0A3B21}"/>
               </a:ext>
             </a:extLst>
           </p:cNvPr>
@@ -9395,7 +9595,7 @@
           <p:cNvPr id="6" name="">
             <a:extLst xmlns:a="http://schemas.openxmlformats.org/drawingml/2006/main">
               <a:ext uri="{FF2B5EF4-FFF2-40B4-BE49-F238E27FC236}">
-                <a16:creationId xmlns:a16="http://schemas.microsoft.com/office/drawing/2014/main" id="{F5724709-152D-48C7-8AA8-CDF65749BC2D}"/>
+                <a16:creationId xmlns:a16="http://schemas.microsoft.com/office/drawing/2014/main" id="{3BF10DD1-ED3D-4211-99DD-49889577ADB6}"/>
               </a:ext>
             </a:extLst>
           </p:cNvPr>
@@ -9516,7 +9716,7 @@
           <p:cNvPr id="7" name="">
             <a:extLst xmlns:a="http://schemas.openxmlformats.org/drawingml/2006/main">
               <a:ext uri="{FF2B5EF4-FFF2-40B4-BE49-F238E27FC236}">
-                <a16:creationId xmlns:a16="http://schemas.microsoft.com/office/drawing/2014/main" id="{7782D288-64A7-4405-9896-0B7D4FC459A5}"/>
+                <a16:creationId xmlns:a16="http://schemas.microsoft.com/office/drawing/2014/main" id="{9EE098DD-0898-4F47-832F-C170AFAAA55D}"/>
               </a:ext>
             </a:extLst>
           </p:cNvPr>
@@ -9637,7 +9837,7 @@
           <p:cNvPr id="8" name="">
             <a:extLst xmlns:a="http://schemas.openxmlformats.org/drawingml/2006/main">
               <a:ext uri="{FF2B5EF4-FFF2-40B4-BE49-F238E27FC236}">
-                <a16:creationId xmlns:a16="http://schemas.microsoft.com/office/drawing/2014/main" id="{DCC10876-39D4-4612-BF84-C5CBED571CCC}"/>
+                <a16:creationId xmlns:a16="http://schemas.microsoft.com/office/drawing/2014/main" id="{5C318117-ADE8-415B-8839-B890E551255C}"/>
               </a:ext>
             </a:extLst>
           </p:cNvPr>
@@ -9773,7 +9973,7 @@
     </p:spTree>
     <p:extLst>
       <p:ext uri="{BB962C8B-B14F-4D97-AF65-F5344CB8AC3E}">
-        <p14:creationId xmlns:p14="http://schemas.microsoft.com/office/powerpoint/2010/main" val="2105278264"/>
+        <p14:creationId xmlns:p14="http://schemas.microsoft.com/office/powerpoint/2010/main" val="2108332624"/>
       </p:ext>
     </p:extLst>
   </p:cSld>
@@ -9804,7 +10004,7 @@
           <p:cNvPr id="8" name="">
             <a:extLst xmlns:a="http://schemas.openxmlformats.org/drawingml/2006/main">
               <a:ext uri="{FF2B5EF4-FFF2-40B4-BE49-F238E27FC236}">
-                <a16:creationId xmlns:a16="http://schemas.microsoft.com/office/drawing/2014/main" id="{5E839E81-97E4-47BE-B5DF-2F42DC5BC506}"/>
+                <a16:creationId xmlns:a16="http://schemas.microsoft.com/office/drawing/2014/main" id="{8BF2ED91-2CCF-4390-8DCB-9276D4246827}"/>
               </a:ext>
             </a:extLst>
           </p:cNvPr>
@@ -9925,7 +10125,7 @@
           <p:cNvPr id="2" name="">
             <a:extLst xmlns:a="http://schemas.openxmlformats.org/drawingml/2006/main">
               <a:ext uri="{FF2B5EF4-FFF2-40B4-BE49-F238E27FC236}">
-                <a16:creationId xmlns:a16="http://schemas.microsoft.com/office/drawing/2014/main" id="{7B16E316-9B2E-4C61-8D75-AFF0A331DFC6}"/>
+                <a16:creationId xmlns:a16="http://schemas.microsoft.com/office/drawing/2014/main" id="{85A84D51-A2BF-4CB3-8B59-4AE584D9B476}"/>
               </a:ext>
             </a:extLst>
           </p:cNvPr>
@@ -10046,7 +10246,7 @@
           <p:cNvPr id="3" name="">
             <a:extLst xmlns:a="http://schemas.openxmlformats.org/drawingml/2006/main">
               <a:ext uri="{FF2B5EF4-FFF2-40B4-BE49-F238E27FC236}">
-                <a16:creationId xmlns:a16="http://schemas.microsoft.com/office/drawing/2014/main" id="{AA207BE9-D592-43C3-8AA0-DB00E8AEE026}"/>
+                <a16:creationId xmlns:a16="http://schemas.microsoft.com/office/drawing/2014/main" id="{1DDCFAB5-464C-4388-925E-F5487D6D12BB}"/>
               </a:ext>
             </a:extLst>
           </p:cNvPr>
@@ -10167,7 +10367,7 @@
           <p:cNvPr id="4" name="">
             <a:extLst xmlns:a="http://schemas.openxmlformats.org/drawingml/2006/main">
               <a:ext uri="{FF2B5EF4-FFF2-40B4-BE49-F238E27FC236}">
-                <a16:creationId xmlns:a16="http://schemas.microsoft.com/office/drawing/2014/main" id="{0D8F2877-CF99-478C-8DCC-0BC05A8E362C}"/>
+                <a16:creationId xmlns:a16="http://schemas.microsoft.com/office/drawing/2014/main" id="{48F73758-982A-4EAB-88BE-BEFDDE6C7CEB}"/>
               </a:ext>
             </a:extLst>
           </p:cNvPr>
@@ -10288,7 +10488,7 @@
           <p:cNvPr id="5" name="">
             <a:extLst xmlns:a="http://schemas.openxmlformats.org/drawingml/2006/main">
               <a:ext uri="{FF2B5EF4-FFF2-40B4-BE49-F238E27FC236}">
-                <a16:creationId xmlns:a16="http://schemas.microsoft.com/office/drawing/2014/main" id="{3A1B28C7-311A-4878-B49B-8EDF49904347}"/>
+                <a16:creationId xmlns:a16="http://schemas.microsoft.com/office/drawing/2014/main" id="{3913B69F-DA5B-4637-B88C-1E6F217B088D}"/>
               </a:ext>
             </a:extLst>
           </p:cNvPr>
@@ -10443,7 +10643,7 @@
           <p:cNvPr id="6" name="">
             <a:extLst xmlns:a="http://schemas.openxmlformats.org/drawingml/2006/main">
               <a:ext uri="{FF2B5EF4-FFF2-40B4-BE49-F238E27FC236}">
-                <a16:creationId xmlns:a16="http://schemas.microsoft.com/office/drawing/2014/main" id="{0D3C1C8D-FAE8-4BEA-A9B5-DDFFF85041D6}"/>
+                <a16:creationId xmlns:a16="http://schemas.microsoft.com/office/drawing/2014/main" id="{AFAA642B-C0DB-4168-85EE-A103DF082377}"/>
               </a:ext>
             </a:extLst>
           </p:cNvPr>
@@ -10564,7 +10764,7 @@
           <p:cNvPr id="7" name="">
             <a:extLst xmlns:a="http://schemas.openxmlformats.org/drawingml/2006/main">
               <a:ext uri="{FF2B5EF4-FFF2-40B4-BE49-F238E27FC236}">
-                <a16:creationId xmlns:a16="http://schemas.microsoft.com/office/drawing/2014/main" id="{74FE25D5-BB38-449D-9524-1AD5B60E64B6}"/>
+                <a16:creationId xmlns:a16="http://schemas.microsoft.com/office/drawing/2014/main" id="{1981807A-6874-4C83-B63F-55E9494BADF1}"/>
               </a:ext>
             </a:extLst>
           </p:cNvPr>
@@ -10717,7 +10917,7 @@
     </p:spTree>
     <p:extLst>
       <p:ext uri="{BB962C8B-B14F-4D97-AF65-F5344CB8AC3E}">
-        <p14:creationId xmlns:p14="http://schemas.microsoft.com/office/powerpoint/2010/main" val="599573434"/>
+        <p14:creationId xmlns:p14="http://schemas.microsoft.com/office/powerpoint/2010/main" val="1949321274"/>
       </p:ext>
     </p:extLst>
   </p:cSld>
@@ -10748,7 +10948,7 @@
           <p:cNvPr id="10" name="">
             <a:extLst xmlns:a="http://schemas.openxmlformats.org/drawingml/2006/main">
               <a:ext uri="{FF2B5EF4-FFF2-40B4-BE49-F238E27FC236}">
-                <a16:creationId xmlns:a16="http://schemas.microsoft.com/office/drawing/2014/main" id="{F7A580DF-DD21-4105-BF92-C10A9E746B32}"/>
+                <a16:creationId xmlns:a16="http://schemas.microsoft.com/office/drawing/2014/main" id="{DED0929A-2E7E-467C-9AA3-D7380BA96F59}"/>
               </a:ext>
             </a:extLst>
           </p:cNvPr>
@@ -10869,7 +11069,7 @@
           <p:cNvPr id="2" name="">
             <a:extLst xmlns:a="http://schemas.openxmlformats.org/drawingml/2006/main">
               <a:ext uri="{FF2B5EF4-FFF2-40B4-BE49-F238E27FC236}">
-                <a16:creationId xmlns:a16="http://schemas.microsoft.com/office/drawing/2014/main" id="{1CE3F281-EE37-49C7-A765-9052A508CCFB}"/>
+                <a16:creationId xmlns:a16="http://schemas.microsoft.com/office/drawing/2014/main" id="{22297B49-2B9E-47B4-BF15-92EB4D89C972}"/>
               </a:ext>
             </a:extLst>
           </p:cNvPr>
@@ -10990,7 +11190,7 @@
           <p:cNvPr id="3" name="">
             <a:extLst xmlns:a="http://schemas.openxmlformats.org/drawingml/2006/main">
               <a:ext uri="{FF2B5EF4-FFF2-40B4-BE49-F238E27FC236}">
-                <a16:creationId xmlns:a16="http://schemas.microsoft.com/office/drawing/2014/main" id="{26905E62-4A69-4DE8-86A6-A1BFEC3925C6}"/>
+                <a16:creationId xmlns:a16="http://schemas.microsoft.com/office/drawing/2014/main" id="{F6E76616-D49C-4A64-8B9A-F9E1764C76E4}"/>
               </a:ext>
             </a:extLst>
           </p:cNvPr>
@@ -11111,7 +11311,7 @@
           <p:cNvPr id="4" name="">
             <a:extLst xmlns:a="http://schemas.openxmlformats.org/drawingml/2006/main">
               <a:ext uri="{FF2B5EF4-FFF2-40B4-BE49-F238E27FC236}">
-                <a16:creationId xmlns:a16="http://schemas.microsoft.com/office/drawing/2014/main" id="{6A3D799C-51A8-465B-9362-FAF51D8E6511}"/>
+                <a16:creationId xmlns:a16="http://schemas.microsoft.com/office/drawing/2014/main" id="{181C7241-168B-4565-85BB-62F31DE2CDF8}"/>
               </a:ext>
             </a:extLst>
           </p:cNvPr>
@@ -11232,7 +11432,7 @@
           <p:cNvPr id="5" name="">
             <a:extLst xmlns:a="http://schemas.openxmlformats.org/drawingml/2006/main">
               <a:ext uri="{FF2B5EF4-FFF2-40B4-BE49-F238E27FC236}">
-                <a16:creationId xmlns:a16="http://schemas.microsoft.com/office/drawing/2014/main" id="{B944574D-241C-4042-8B01-9C8889A08445}"/>
+                <a16:creationId xmlns:a16="http://schemas.microsoft.com/office/drawing/2014/main" id="{8E899A84-6BD8-49A3-9F77-6C75E4B1DA5E}"/>
               </a:ext>
             </a:extLst>
           </p:cNvPr>
@@ -11353,7 +11553,7 @@
           <p:cNvPr id="6" name="">
             <a:extLst xmlns:a="http://schemas.openxmlformats.org/drawingml/2006/main">
               <a:ext uri="{FF2B5EF4-FFF2-40B4-BE49-F238E27FC236}">
-                <a16:creationId xmlns:a16="http://schemas.microsoft.com/office/drawing/2014/main" id="{DC57D545-8F56-46CE-A81E-D0D591FBE587}"/>
+                <a16:creationId xmlns:a16="http://schemas.microsoft.com/office/drawing/2014/main" id="{44373B52-C0E3-4729-AAAD-22430A3AEC59}"/>
               </a:ext>
             </a:extLst>
           </p:cNvPr>
@@ -11474,7 +11674,7 @@
           <p:cNvPr id="7" name="">
             <a:extLst xmlns:a="http://schemas.openxmlformats.org/drawingml/2006/main">
               <a:ext uri="{FF2B5EF4-FFF2-40B4-BE49-F238E27FC236}">
-                <a16:creationId xmlns:a16="http://schemas.microsoft.com/office/drawing/2014/main" id="{1B60C4BF-8E93-4785-ABD7-31AE8BC1C953}"/>
+                <a16:creationId xmlns:a16="http://schemas.microsoft.com/office/drawing/2014/main" id="{8138CB88-8781-4A33-8A15-6FE0102E034E}"/>
               </a:ext>
             </a:extLst>
           </p:cNvPr>
@@ -11646,7 +11846,7 @@
           <p:cNvPr id="8" name="">
             <a:extLst xmlns:a="http://schemas.openxmlformats.org/drawingml/2006/main">
               <a:ext uri="{FF2B5EF4-FFF2-40B4-BE49-F238E27FC236}">
-                <a16:creationId xmlns:a16="http://schemas.microsoft.com/office/drawing/2014/main" id="{1CF0FAC8-784E-4FF4-B3B1-EA3D27F2BFF3}"/>
+                <a16:creationId xmlns:a16="http://schemas.microsoft.com/office/drawing/2014/main" id="{29F45F3A-4607-478B-9CC4-F60F22C74709}"/>
               </a:ext>
             </a:extLst>
           </p:cNvPr>
@@ -11767,7 +11967,7 @@
           <p:cNvPr id="9" name="">
             <a:extLst xmlns:a="http://schemas.openxmlformats.org/drawingml/2006/main">
               <a:ext uri="{FF2B5EF4-FFF2-40B4-BE49-F238E27FC236}">
-                <a16:creationId xmlns:a16="http://schemas.microsoft.com/office/drawing/2014/main" id="{ECF402B0-6BEA-4878-9B93-933B79C81596}"/>
+                <a16:creationId xmlns:a16="http://schemas.microsoft.com/office/drawing/2014/main" id="{952FDEB6-DF54-4C80-83F7-0AF3B8520730}"/>
               </a:ext>
             </a:extLst>
           </p:cNvPr>
@@ -11937,7 +12137,7 @@
     </p:spTree>
     <p:extLst>
       <p:ext uri="{BB962C8B-B14F-4D97-AF65-F5344CB8AC3E}">
-        <p14:creationId xmlns:p14="http://schemas.microsoft.com/office/powerpoint/2010/main" val="2137561410"/>
+        <p14:creationId xmlns:p14="http://schemas.microsoft.com/office/powerpoint/2010/main" val="1839974343"/>
       </p:ext>
     </p:extLst>
   </p:cSld>
@@ -11965,10 +12165,10 @@
       </p:grpSpPr>
       <p:sp>
         <p:nvSpPr>
-          <p:cNvPr id="9" name="">
+          <p:cNvPr id="7" name="">
             <a:extLst xmlns:a="http://schemas.openxmlformats.org/drawingml/2006/main">
               <a:ext uri="{FF2B5EF4-FFF2-40B4-BE49-F238E27FC236}">
-                <a16:creationId xmlns:a16="http://schemas.microsoft.com/office/drawing/2014/main" id="{5EAFE0FC-0BA3-4C26-9A56-5C9C1A472EAF}"/>
+                <a16:creationId xmlns:a16="http://schemas.microsoft.com/office/drawing/2014/main" id="{871C55F1-6D1E-4B9A-A3B9-18E96BD34F57}"/>
               </a:ext>
             </a:extLst>
           </p:cNvPr>
@@ -12089,7 +12289,7 @@
           <p:cNvPr id="2" name="">
             <a:extLst xmlns:a="http://schemas.openxmlformats.org/drawingml/2006/main">
               <a:ext uri="{FF2B5EF4-FFF2-40B4-BE49-F238E27FC236}">
-                <a16:creationId xmlns:a16="http://schemas.microsoft.com/office/drawing/2014/main" id="{4E47A765-A261-45DC-AAF7-EDAB3944AF7F}"/>
+                <a16:creationId xmlns:a16="http://schemas.microsoft.com/office/drawing/2014/main" id="{5CC4DC8E-7865-46FA-B7C0-89275DC56F86}"/>
               </a:ext>
             </a:extLst>
           </p:cNvPr>
@@ -12210,7 +12410,7 @@
           <p:cNvPr id="3" name="">
             <a:extLst xmlns:a="http://schemas.openxmlformats.org/drawingml/2006/main">
               <a:ext uri="{FF2B5EF4-FFF2-40B4-BE49-F238E27FC236}">
-                <a16:creationId xmlns:a16="http://schemas.microsoft.com/office/drawing/2014/main" id="{3D591363-5043-4AA1-B92D-4933A1B54F97}"/>
+                <a16:creationId xmlns:a16="http://schemas.microsoft.com/office/drawing/2014/main" id="{106ECEE0-631B-43D5-AE97-6A7278E0F284}"/>
               </a:ext>
             </a:extLst>
           </p:cNvPr>
@@ -12331,7 +12531,7 @@
           <p:cNvPr id="4" name="">
             <a:extLst xmlns:a="http://schemas.openxmlformats.org/drawingml/2006/main">
               <a:ext uri="{FF2B5EF4-FFF2-40B4-BE49-F238E27FC236}">
-                <a16:creationId xmlns:a16="http://schemas.microsoft.com/office/drawing/2014/main" id="{74EAEDA4-3558-4EE3-ACE2-95EA9DB58D74}"/>
+                <a16:creationId xmlns:a16="http://schemas.microsoft.com/office/drawing/2014/main" id="{06379E28-39DE-49EB-8E77-1EA0ED61C085}"/>
               </a:ext>
             </a:extLst>
           </p:cNvPr>
@@ -12447,562 +12647,612 @@
           </a:p>
         </p:txBody>
       </p:sp>
-      <p:sp>
-        <p:nvSpPr>
+      <p:graphicFrame>
+        <p:nvGraphicFramePr>
           <p:cNvPr id="5" name="">
             <a:extLst xmlns:a="http://schemas.openxmlformats.org/drawingml/2006/main">
               <a:ext uri="{FF2B5EF4-FFF2-40B4-BE49-F238E27FC236}">
-                <a16:creationId xmlns:a16="http://schemas.microsoft.com/office/drawing/2014/main" id="{551932A2-62C0-48EB-94E5-9DB07C8CC027}"/>
+                <a16:creationId xmlns:a16="http://schemas.microsoft.com/office/drawing/2014/main" id="{1202B9BB-3D57-4D33-A4A7-AE8237BD5272}"/>
               </a:ext>
             </a:extLst>
           </p:cNvPr>
-          <p:cNvSpPr>
-            <a:spLocks xmlns:a="http://schemas.openxmlformats.org/drawingml/2006/main" noGrp="1"/>
-          </p:cNvSpPr>
+          <p:cNvGraphicFramePr/>
           <p:nvPr/>
-        </p:nvSpPr>
-        <p:spPr>
-          <a:xfrm xmlns:a="http://schemas.openxmlformats.org/drawingml/2006/main">
-            <a:off x="952500" y="2857500"/>
-            <a:ext cx="2381250" cy="361950"/>
-          </a:xfrm>
-          <a:prstGeom xmlns:a="http://schemas.openxmlformats.org/drawingml/2006/main" prst="rect">
-            <a:avLst/>
-          </a:prstGeom>
-          <a:noFill xmlns:a="http://schemas.openxmlformats.org/drawingml/2006/main"/>
-          <a:ln xmlns:a="http://schemas.openxmlformats.org/drawingml/2006/main" w="0">
-            <a:noFill/>
-            <a:prstDash val="solid"/>
-          </a:ln>
-        </p:spPr>
-        <p:txBody>
-          <a:bodyPr xmlns:a="http://schemas.openxmlformats.org/drawingml/2006/main"/>
-          <a:lstStyle xmlns:a="http://schemas.openxmlformats.org/drawingml/2006/main">
-            <a:defPPr>
-              <a:defRPr sz="1800" b="1">
-                <a:solidFill>
-                  <a:srgbClr val="2F5597"/>
-                </a:solidFill>
-              </a:defRPr>
-            </a:defPPr>
-            <a:lvl1pPr>
-              <a:defRPr sz="1800" b="1">
-                <a:solidFill>
-                  <a:srgbClr val="2F5597"/>
-                </a:solidFill>
-              </a:defRPr>
-            </a:lvl1pPr>
-            <a:lvl2pPr>
-              <a:defRPr sz="1800" b="1">
-                <a:solidFill>
-                  <a:srgbClr val="2F5597"/>
-                </a:solidFill>
-              </a:defRPr>
-            </a:lvl2pPr>
-            <a:lvl3pPr>
-              <a:defRPr sz="1800" b="1">
-                <a:solidFill>
-                  <a:srgbClr val="2F5597"/>
-                </a:solidFill>
-              </a:defRPr>
-            </a:lvl3pPr>
-            <a:lvl4pPr>
-              <a:defRPr sz="1800" b="1">
-                <a:solidFill>
-                  <a:srgbClr val="2F5597"/>
-                </a:solidFill>
-              </a:defRPr>
-            </a:lvl4pPr>
-            <a:lvl5pPr>
-              <a:defRPr sz="1800" b="1">
-                <a:solidFill>
-                  <a:srgbClr val="2F5597"/>
-                </a:solidFill>
-              </a:defRPr>
-            </a:lvl5pPr>
-            <a:lvl6pPr>
-              <a:defRPr sz="1800" b="1">
-                <a:solidFill>
-                  <a:srgbClr val="2F5597"/>
-                </a:solidFill>
-              </a:defRPr>
-            </a:lvl6pPr>
-            <a:lvl7pPr>
-              <a:defRPr sz="1800" b="1">
-                <a:solidFill>
-                  <a:srgbClr val="2F5597"/>
-                </a:solidFill>
-              </a:defRPr>
-            </a:lvl7pPr>
-            <a:lvl8pPr>
-              <a:defRPr sz="1800" b="1">
-                <a:solidFill>
-                  <a:srgbClr val="2F5597"/>
-                </a:solidFill>
-              </a:defRPr>
-            </a:lvl8pPr>
-            <a:lvl9pPr>
-              <a:defRPr sz="1800" b="1">
-                <a:solidFill>
-                  <a:srgbClr val="2F5597"/>
-                </a:solidFill>
-              </a:defRPr>
-            </a:lvl9pPr>
-          </a:lstStyle>
-          <a:p xmlns:a="http://schemas.openxmlformats.org/drawingml/2006/main">
-            <a:pPr>
-              <a:defRPr sz="1800" b="1">
-                <a:solidFill>
-                  <a:srgbClr val="2F5597"/>
-                </a:solidFill>
-              </a:defRPr>
-            </a:pPr>
-            <a:r>
-              <a:rPr sz="1800" b="1">
-                <a:solidFill>
-                  <a:srgbClr val="2F5597"/>
-                </a:solidFill>
-              </a:rPr>
-              <a:t>CNN</a:t>
-            </a:r>
-          </a:p>
-        </p:txBody>
-      </p:sp>
-      <p:sp>
-        <p:nvSpPr>
-          <p:cNvPr id="6" name="">
+        </p:nvGraphicFramePr>
+        <p:xfrm>
+          <a:off xmlns:a="http://schemas.openxmlformats.org/drawingml/2006/main" x="819150" y="2333625"/>
+          <a:ext xmlns:a="http://schemas.openxmlformats.org/drawingml/2006/main" cx="10382250" cy="1285875"/>
+        </p:xfrm>
+        <a:graphic xmlns:a="http://schemas.openxmlformats.org/drawingml/2006/main">
+          <a:graphicData uri="http://schemas.openxmlformats.org/drawingml/2006/table">
+            <a:tbl>
+              <a:tblPr firstRow="1" bandRow="1"/>
+              <a:tblGrid>
+                <a:gridCol w="2076450"/>
+                <a:gridCol w="2076450"/>
+                <a:gridCol w="2076450"/>
+                <a:gridCol w="2076450"/>
+                <a:gridCol w="2076450"/>
+              </a:tblGrid>
+              <a:tr h="428625">
+                <a:tc>
+                  <a:txBody>
+                    <a:bodyPr/>
+                    <a:lstStyle/>
+                    <a:p>
+                      <a:r>
+                        <a:rPr sz="1275" b="1">
+                          <a:solidFill>
+                            <a:srgbClr val="FFFFFF"/>
+                          </a:solidFill>
+                        </a:rPr>
+                        <a:t>Mô hình</a:t>
+                      </a:r>
+                    </a:p>
+                  </a:txBody>
+                  <a:tcPr marL="91440" marR="91440" marT="45720" marB="45720">
+                    <a:lnL w="9525">
+                      <a:solidFill>
+                        <a:srgbClr val="D9D9D9"/>
+                      </a:solidFill>
+                      <a:prstDash val="solid"/>
+                    </a:lnL>
+                    <a:lnR w="9525">
+                      <a:solidFill>
+                        <a:srgbClr val="D9D9D9"/>
+                      </a:solidFill>
+                      <a:prstDash val="solid"/>
+                    </a:lnR>
+                    <a:lnT w="9525">
+                      <a:solidFill>
+                        <a:srgbClr val="D9D9D9"/>
+                      </a:solidFill>
+                      <a:prstDash val="solid"/>
+                    </a:lnT>
+                    <a:lnB w="9525">
+                      <a:solidFill>
+                        <a:srgbClr val="D9D9D9"/>
+                      </a:solidFill>
+                      <a:prstDash val="solid"/>
+                    </a:lnB>
+                    <a:solidFill>
+                      <a:srgbClr val="1F4E79"/>
+                    </a:solidFill>
+                  </a:tcPr>
+                </a:tc>
+                <a:tc>
+                  <a:txBody>
+                    <a:bodyPr/>
+                    <a:lstStyle/>
+                    <a:p>
+                      <a:r>
+                        <a:rPr sz="1275" b="1">
+                          <a:solidFill>
+                            <a:srgbClr val="FFFFFF"/>
+                          </a:solidFill>
+                        </a:rPr>
+                        <a:t>Accuracy</a:t>
+                      </a:r>
+                    </a:p>
+                  </a:txBody>
+                  <a:tcPr marL="91440" marR="91440" marT="45720" marB="45720">
+                    <a:lnR w="9525">
+                      <a:solidFill>
+                        <a:srgbClr val="D9D9D9"/>
+                      </a:solidFill>
+                      <a:prstDash val="solid"/>
+                    </a:lnR>
+                    <a:lnT w="9525">
+                      <a:solidFill>
+                        <a:srgbClr val="D9D9D9"/>
+                      </a:solidFill>
+                      <a:prstDash val="solid"/>
+                    </a:lnT>
+                    <a:lnB w="9525">
+                      <a:solidFill>
+                        <a:srgbClr val="D9D9D9"/>
+                      </a:solidFill>
+                      <a:prstDash val="solid"/>
+                    </a:lnB>
+                    <a:solidFill>
+                      <a:srgbClr val="1F4E79"/>
+                    </a:solidFill>
+                  </a:tcPr>
+                </a:tc>
+                <a:tc>
+                  <a:txBody>
+                    <a:bodyPr/>
+                    <a:lstStyle/>
+                    <a:p>
+                      <a:r>
+                        <a:rPr sz="1275" b="1">
+                          <a:solidFill>
+                            <a:srgbClr val="FFFFFF"/>
+                          </a:solidFill>
+                        </a:rPr>
+                        <a:t>Macro F1</a:t>
+                      </a:r>
+                    </a:p>
+                  </a:txBody>
+                  <a:tcPr marL="91440" marR="91440" marT="45720" marB="45720">
+                    <a:lnR w="9525">
+                      <a:solidFill>
+                        <a:srgbClr val="D9D9D9"/>
+                      </a:solidFill>
+                      <a:prstDash val="solid"/>
+                    </a:lnR>
+                    <a:lnT w="9525">
+                      <a:solidFill>
+                        <a:srgbClr val="D9D9D9"/>
+                      </a:solidFill>
+                      <a:prstDash val="solid"/>
+                    </a:lnT>
+                    <a:lnB w="9525">
+                      <a:solidFill>
+                        <a:srgbClr val="D9D9D9"/>
+                      </a:solidFill>
+                      <a:prstDash val="solid"/>
+                    </a:lnB>
+                    <a:solidFill>
+                      <a:srgbClr val="1F4E79"/>
+                    </a:solidFill>
+                  </a:tcPr>
+                </a:tc>
+                <a:tc>
+                  <a:txBody>
+                    <a:bodyPr/>
+                    <a:lstStyle/>
+                    <a:p>
+                      <a:r>
+                        <a:rPr sz="1275" b="1">
+                          <a:solidFill>
+                            <a:srgbClr val="FFFFFF"/>
+                          </a:solidFill>
+                        </a:rPr>
+                        <a:t>Đúng/Test</a:t>
+                      </a:r>
+                    </a:p>
+                  </a:txBody>
+                  <a:tcPr marL="91440" marR="91440" marT="45720" marB="45720">
+                    <a:lnR w="9525">
+                      <a:solidFill>
+                        <a:srgbClr val="D9D9D9"/>
+                      </a:solidFill>
+                      <a:prstDash val="solid"/>
+                    </a:lnR>
+                    <a:lnT w="9525">
+                      <a:solidFill>
+                        <a:srgbClr val="D9D9D9"/>
+                      </a:solidFill>
+                      <a:prstDash val="solid"/>
+                    </a:lnT>
+                    <a:lnB w="9525">
+                      <a:solidFill>
+                        <a:srgbClr val="D9D9D9"/>
+                      </a:solidFill>
+                      <a:prstDash val="solid"/>
+                    </a:lnB>
+                    <a:solidFill>
+                      <a:srgbClr val="1F4E79"/>
+                    </a:solidFill>
+                  </a:tcPr>
+                </a:tc>
+                <a:tc>
+                  <a:txBody>
+                    <a:bodyPr/>
+                    <a:lstStyle/>
+                    <a:p>
+                      <a:r>
+                        <a:rPr sz="1275" b="1">
+                          <a:solidFill>
+                            <a:srgbClr val="FFFFFF"/>
+                          </a:solidFill>
+                        </a:rPr>
+                        <a:t>Tham số</a:t>
+                      </a:r>
+                    </a:p>
+                  </a:txBody>
+                  <a:tcPr marL="91440" marR="91440" marT="45720" marB="45720">
+                    <a:lnR w="9525">
+                      <a:solidFill>
+                        <a:srgbClr val="D9D9D9"/>
+                      </a:solidFill>
+                      <a:prstDash val="solid"/>
+                    </a:lnR>
+                    <a:lnT w="9525">
+                      <a:solidFill>
+                        <a:srgbClr val="D9D9D9"/>
+                      </a:solidFill>
+                      <a:prstDash val="solid"/>
+                    </a:lnT>
+                    <a:lnB w="9525">
+                      <a:solidFill>
+                        <a:srgbClr val="D9D9D9"/>
+                      </a:solidFill>
+                      <a:prstDash val="solid"/>
+                    </a:lnB>
+                    <a:solidFill>
+                      <a:srgbClr val="1F4E79"/>
+                    </a:solidFill>
+                  </a:tcPr>
+                </a:tc>
+              </a:tr>
+              <a:tr h="428625">
+                <a:tc>
+                  <a:txBody>
+                    <a:bodyPr/>
+                    <a:lstStyle/>
+                    <a:p>
+                      <a:r>
+                        <a:rPr sz="1200">
+                          <a:solidFill>
+                            <a:srgbClr val="17202A"/>
+                          </a:solidFill>
+                        </a:rPr>
+                        <a:t>CNN</a:t>
+                      </a:r>
+                    </a:p>
+                  </a:txBody>
+                  <a:tcPr marL="91440" marR="91440" marT="45720" marB="45720">
+                    <a:lnL w="9525">
+                      <a:solidFill>
+                        <a:srgbClr val="D9D9D9"/>
+                      </a:solidFill>
+                      <a:prstDash val="solid"/>
+                    </a:lnL>
+                    <a:lnR w="9525">
+                      <a:solidFill>
+                        <a:srgbClr val="D9D9D9"/>
+                      </a:solidFill>
+                      <a:prstDash val="solid"/>
+                    </a:lnR>
+                    <a:lnB w="9525">
+                      <a:solidFill>
+                        <a:srgbClr val="D9D9D9"/>
+                      </a:solidFill>
+                      <a:prstDash val="solid"/>
+                    </a:lnB>
+                    <a:solidFill>
+                      <a:srgbClr val="F3F6FA"/>
+                    </a:solidFill>
+                  </a:tcPr>
+                </a:tc>
+                <a:tc>
+                  <a:txBody>
+                    <a:bodyPr/>
+                    <a:lstStyle/>
+                    <a:p>
+                      <a:r>
+                        <a:rPr sz="1200">
+                          <a:solidFill>
+                            <a:srgbClr val="17202A"/>
+                          </a:solidFill>
+                        </a:rPr>
+                        <a:t>96,9764%</a:t>
+                      </a:r>
+                    </a:p>
+                  </a:txBody>
+                  <a:tcPr marL="91440" marR="91440" marT="45720" marB="45720">
+                    <a:lnR w="9525">
+                      <a:solidFill>
+                        <a:srgbClr val="D9D9D9"/>
+                      </a:solidFill>
+                      <a:prstDash val="solid"/>
+                    </a:lnR>
+                    <a:lnB w="9525">
+                      <a:solidFill>
+                        <a:srgbClr val="D9D9D9"/>
+                      </a:solidFill>
+                      <a:prstDash val="solid"/>
+                    </a:lnB>
+                    <a:solidFill>
+                      <a:srgbClr val="F3F6FA"/>
+                    </a:solidFill>
+                  </a:tcPr>
+                </a:tc>
+                <a:tc>
+                  <a:txBody>
+                    <a:bodyPr/>
+                    <a:lstStyle/>
+                    <a:p>
+                      <a:r>
+                        <a:rPr sz="1200">
+                          <a:solidFill>
+                            <a:srgbClr val="17202A"/>
+                          </a:solidFill>
+                        </a:rPr>
+                        <a:t>96,5034%</a:t>
+                      </a:r>
+                    </a:p>
+                  </a:txBody>
+                  <a:tcPr marL="91440" marR="91440" marT="45720" marB="45720">
+                    <a:lnR w="9525">
+                      <a:solidFill>
+                        <a:srgbClr val="D9D9D9"/>
+                      </a:solidFill>
+                      <a:prstDash val="solid"/>
+                    </a:lnR>
+                    <a:lnB w="9525">
+                      <a:solidFill>
+                        <a:srgbClr val="D9D9D9"/>
+                      </a:solidFill>
+                      <a:prstDash val="solid"/>
+                    </a:lnB>
+                    <a:solidFill>
+                      <a:srgbClr val="F3F6FA"/>
+                    </a:solidFill>
+                  </a:tcPr>
+                </a:tc>
+                <a:tc>
+                  <a:txBody>
+                    <a:bodyPr/>
+                    <a:lstStyle/>
+                    <a:p>
+                      <a:r>
+                        <a:rPr sz="1200">
+                          <a:solidFill>
+                            <a:srgbClr val="17202A"/>
+                          </a:solidFill>
+                        </a:rPr>
+                        <a:t>1.315/1.356</a:t>
+                      </a:r>
+                    </a:p>
+                  </a:txBody>
+                  <a:tcPr marL="91440" marR="91440" marT="45720" marB="45720">
+                    <a:lnR w="9525">
+                      <a:solidFill>
+                        <a:srgbClr val="D9D9D9"/>
+                      </a:solidFill>
+                      <a:prstDash val="solid"/>
+                    </a:lnR>
+                    <a:lnB w="9525">
+                      <a:solidFill>
+                        <a:srgbClr val="D9D9D9"/>
+                      </a:solidFill>
+                      <a:prstDash val="solid"/>
+                    </a:lnB>
+                    <a:solidFill>
+                      <a:srgbClr val="F3F6FA"/>
+                    </a:solidFill>
+                  </a:tcPr>
+                </a:tc>
+                <a:tc>
+                  <a:txBody>
+                    <a:bodyPr/>
+                    <a:lstStyle/>
+                    <a:p>
+                      <a:r>
+                        <a:rPr sz="1200">
+                          <a:solidFill>
+                            <a:srgbClr val="17202A"/>
+                          </a:solidFill>
+                        </a:rPr>
+                        <a:t>389.924</a:t>
+                      </a:r>
+                    </a:p>
+                  </a:txBody>
+                  <a:tcPr marL="91440" marR="91440" marT="45720" marB="45720">
+                    <a:lnR w="9525">
+                      <a:solidFill>
+                        <a:srgbClr val="D9D9D9"/>
+                      </a:solidFill>
+                      <a:prstDash val="solid"/>
+                    </a:lnR>
+                    <a:lnB w="9525">
+                      <a:solidFill>
+                        <a:srgbClr val="D9D9D9"/>
+                      </a:solidFill>
+                      <a:prstDash val="solid"/>
+                    </a:lnB>
+                    <a:solidFill>
+                      <a:srgbClr val="F3F6FA"/>
+                    </a:solidFill>
+                  </a:tcPr>
+                </a:tc>
+              </a:tr>
+              <a:tr h="428625">
+                <a:tc>
+                  <a:txBody>
+                    <a:bodyPr/>
+                    <a:lstStyle/>
+                    <a:p>
+                      <a:r>
+                        <a:rPr sz="1200">
+                          <a:solidFill>
+                            <a:srgbClr val="17202A"/>
+                          </a:solidFill>
+                        </a:rPr>
+                        <a:t>ResNet18</a:t>
+                      </a:r>
+                    </a:p>
+                  </a:txBody>
+                  <a:tcPr marL="91440" marR="91440" marT="45720" marB="45720">
+                    <a:lnL w="9525">
+                      <a:solidFill>
+                        <a:srgbClr val="D9D9D9"/>
+                      </a:solidFill>
+                      <a:prstDash val="solid"/>
+                    </a:lnL>
+                    <a:lnR w="9525">
+                      <a:solidFill>
+                        <a:srgbClr val="D9D9D9"/>
+                      </a:solidFill>
+                      <a:prstDash val="solid"/>
+                    </a:lnR>
+                    <a:lnB w="9525">
+                      <a:solidFill>
+                        <a:srgbClr val="D9D9D9"/>
+                      </a:solidFill>
+                      <a:prstDash val="solid"/>
+                    </a:lnB>
+                    <a:solidFill>
+                      <a:srgbClr val="F3F6FA"/>
+                    </a:solidFill>
+                  </a:tcPr>
+                </a:tc>
+                <a:tc>
+                  <a:txBody>
+                    <a:bodyPr/>
+                    <a:lstStyle/>
+                    <a:p>
+                      <a:r>
+                        <a:rPr sz="1200">
+                          <a:solidFill>
+                            <a:srgbClr val="17202A"/>
+                          </a:solidFill>
+                        </a:rPr>
+                        <a:t>98,6726%</a:t>
+                      </a:r>
+                    </a:p>
+                  </a:txBody>
+                  <a:tcPr marL="91440" marR="91440" marT="45720" marB="45720">
+                    <a:lnR w="9525">
+                      <a:solidFill>
+                        <a:srgbClr val="D9D9D9"/>
+                      </a:solidFill>
+                      <a:prstDash val="solid"/>
+                    </a:lnR>
+                    <a:lnB w="9525">
+                      <a:solidFill>
+                        <a:srgbClr val="D9D9D9"/>
+                      </a:solidFill>
+                      <a:prstDash val="solid"/>
+                    </a:lnB>
+                    <a:solidFill>
+                      <a:srgbClr val="F3F6FA"/>
+                    </a:solidFill>
+                  </a:tcPr>
+                </a:tc>
+                <a:tc>
+                  <a:txBody>
+                    <a:bodyPr/>
+                    <a:lstStyle/>
+                    <a:p>
+                      <a:r>
+                        <a:rPr sz="1200">
+                          <a:solidFill>
+                            <a:srgbClr val="17202A"/>
+                          </a:solidFill>
+                        </a:rPr>
+                        <a:t>98,3978%</a:t>
+                      </a:r>
+                    </a:p>
+                  </a:txBody>
+                  <a:tcPr marL="91440" marR="91440" marT="45720" marB="45720">
+                    <a:lnR w="9525">
+                      <a:solidFill>
+                        <a:srgbClr val="D9D9D9"/>
+                      </a:solidFill>
+                      <a:prstDash val="solid"/>
+                    </a:lnR>
+                    <a:lnB w="9525">
+                      <a:solidFill>
+                        <a:srgbClr val="D9D9D9"/>
+                      </a:solidFill>
+                      <a:prstDash val="solid"/>
+                    </a:lnB>
+                    <a:solidFill>
+                      <a:srgbClr val="F3F6FA"/>
+                    </a:solidFill>
+                  </a:tcPr>
+                </a:tc>
+                <a:tc>
+                  <a:txBody>
+                    <a:bodyPr/>
+                    <a:lstStyle/>
+                    <a:p>
+                      <a:r>
+                        <a:rPr sz="1200">
+                          <a:solidFill>
+                            <a:srgbClr val="17202A"/>
+                          </a:solidFill>
+                        </a:rPr>
+                        <a:t>1.338/1.356</a:t>
+                      </a:r>
+                    </a:p>
+                  </a:txBody>
+                  <a:tcPr marL="91440" marR="91440" marT="45720" marB="45720">
+                    <a:lnR w="9525">
+                      <a:solidFill>
+                        <a:srgbClr val="D9D9D9"/>
+                      </a:solidFill>
+                      <a:prstDash val="solid"/>
+                    </a:lnR>
+                    <a:lnB w="9525">
+                      <a:solidFill>
+                        <a:srgbClr val="D9D9D9"/>
+                      </a:solidFill>
+                      <a:prstDash val="solid"/>
+                    </a:lnB>
+                    <a:solidFill>
+                      <a:srgbClr val="F3F6FA"/>
+                    </a:solidFill>
+                  </a:tcPr>
+                </a:tc>
+                <a:tc>
+                  <a:txBody>
+                    <a:bodyPr/>
+                    <a:lstStyle/>
+                    <a:p>
+                      <a:r>
+                        <a:rPr sz="1200">
+                          <a:solidFill>
+                            <a:srgbClr val="17202A"/>
+                          </a:solidFill>
+                        </a:rPr>
+                        <a:t>11.178.564</a:t>
+                      </a:r>
+                    </a:p>
+                  </a:txBody>
+                  <a:tcPr marL="91440" marR="91440" marT="45720" marB="45720">
+                    <a:lnR w="9525">
+                      <a:solidFill>
+                        <a:srgbClr val="D9D9D9"/>
+                      </a:solidFill>
+                      <a:prstDash val="solid"/>
+                    </a:lnR>
+                    <a:lnB w="9525">
+                      <a:solidFill>
+                        <a:srgbClr val="D9D9D9"/>
+                      </a:solidFill>
+                      <a:prstDash val="solid"/>
+                    </a:lnB>
+                    <a:solidFill>
+                      <a:srgbClr val="F3F6FA"/>
+                    </a:solidFill>
+                  </a:tcPr>
+                </a:tc>
+              </a:tr>
+            </a:tbl>
+          </a:graphicData>
+        </a:graphic>
+      </p:graphicFrame>
+      <p:graphicFrame>
+        <p:nvGraphicFramePr>
+          <p:cNvPr id="6" name="Chart">
             <a:extLst xmlns:a="http://schemas.openxmlformats.org/drawingml/2006/main">
               <a:ext uri="{FF2B5EF4-FFF2-40B4-BE49-F238E27FC236}">
-                <a16:creationId xmlns:a16="http://schemas.microsoft.com/office/drawing/2014/main" id="{8FCBDB71-D245-4281-A90A-92CC592FC939}"/>
+                <a16:creationId xmlns:a16="http://schemas.microsoft.com/office/drawing/2014/main" id="{EBDF0B5F-6748-4B45-818F-E9209FBD72CC}"/>
               </a:ext>
             </a:extLst>
           </p:cNvPr>
-          <p:cNvSpPr>
-            <a:spLocks xmlns:a="http://schemas.openxmlformats.org/drawingml/2006/main" noGrp="1"/>
-          </p:cNvSpPr>
+          <p:cNvGraphicFramePr/>
           <p:nvPr/>
-        </p:nvSpPr>
-        <p:spPr>
-          <a:xfrm xmlns:a="http://schemas.openxmlformats.org/drawingml/2006/main">
-            <a:off x="952500" y="3333750"/>
-            <a:ext cx="4191000" cy="1238250"/>
-          </a:xfrm>
-          <a:prstGeom xmlns:a="http://schemas.openxmlformats.org/drawingml/2006/main" prst="rect">
-            <a:avLst/>
-          </a:prstGeom>
-          <a:noFill xmlns:a="http://schemas.openxmlformats.org/drawingml/2006/main"/>
-          <a:ln xmlns:a="http://schemas.openxmlformats.org/drawingml/2006/main" w="0">
-            <a:noFill/>
-            <a:prstDash val="solid"/>
-          </a:ln>
-        </p:spPr>
-        <p:txBody>
-          <a:bodyPr xmlns:a="http://schemas.openxmlformats.org/drawingml/2006/main"/>
-          <a:lstStyle xmlns:a="http://schemas.openxmlformats.org/drawingml/2006/main">
-            <a:defPPr>
-              <a:defRPr sz="1575" b="0">
-                <a:solidFill>
-                  <a:srgbClr val="17202A"/>
-                </a:solidFill>
-              </a:defRPr>
-            </a:defPPr>
-            <a:lvl1pPr>
-              <a:defRPr sz="1575" b="0">
-                <a:solidFill>
-                  <a:srgbClr val="17202A"/>
-                </a:solidFill>
-              </a:defRPr>
-            </a:lvl1pPr>
-            <a:lvl2pPr>
-              <a:defRPr sz="1575" b="0">
-                <a:solidFill>
-                  <a:srgbClr val="17202A"/>
-                </a:solidFill>
-              </a:defRPr>
-            </a:lvl2pPr>
-            <a:lvl3pPr>
-              <a:defRPr sz="1575" b="0">
-                <a:solidFill>
-                  <a:srgbClr val="17202A"/>
-                </a:solidFill>
-              </a:defRPr>
-            </a:lvl3pPr>
-            <a:lvl4pPr>
-              <a:defRPr sz="1575" b="0">
-                <a:solidFill>
-                  <a:srgbClr val="17202A"/>
-                </a:solidFill>
-              </a:defRPr>
-            </a:lvl4pPr>
-            <a:lvl5pPr>
-              <a:defRPr sz="1575" b="0">
-                <a:solidFill>
-                  <a:srgbClr val="17202A"/>
-                </a:solidFill>
-              </a:defRPr>
-            </a:lvl5pPr>
-            <a:lvl6pPr>
-              <a:defRPr sz="1575" b="0">
-                <a:solidFill>
-                  <a:srgbClr val="17202A"/>
-                </a:solidFill>
-              </a:defRPr>
-            </a:lvl6pPr>
-            <a:lvl7pPr>
-              <a:defRPr sz="1575" b="0">
-                <a:solidFill>
-                  <a:srgbClr val="17202A"/>
-                </a:solidFill>
-              </a:defRPr>
-            </a:lvl7pPr>
-            <a:lvl8pPr>
-              <a:defRPr sz="1575" b="0">
-                <a:solidFill>
-                  <a:srgbClr val="17202A"/>
-                </a:solidFill>
-              </a:defRPr>
-            </a:lvl8pPr>
-            <a:lvl9pPr>
-              <a:defRPr sz="1575" b="0">
-                <a:solidFill>
-                  <a:srgbClr val="17202A"/>
-                </a:solidFill>
-              </a:defRPr>
-            </a:lvl9pPr>
-          </a:lstStyle>
-          <a:p xmlns:a="http://schemas.openxmlformats.org/drawingml/2006/main">
-            <a:pPr>
-              <a:defRPr sz="1575" b="0">
-                <a:solidFill>
-                  <a:srgbClr val="17202A"/>
-                </a:solidFill>
-              </a:defRPr>
-            </a:pPr>
-            <a:r>
-              <a:rPr sz="1575" b="0">
-                <a:solidFill>
-                  <a:srgbClr val="17202A"/>
-                </a:solidFill>
-              </a:rPr>
-              <a:t>Accuracy: 0,969764</a:t>
-            </a:r>
-          </a:p>
-          <a:p xmlns:a="http://schemas.openxmlformats.org/drawingml/2006/main">
-            <a:pPr>
-              <a:defRPr sz="1575" b="0">
-                <a:solidFill>
-                  <a:srgbClr val="17202A"/>
-                </a:solidFill>
-              </a:defRPr>
-            </a:pPr>
-            <a:r>
-              <a:rPr sz="1575" b="0">
-                <a:solidFill>
-                  <a:srgbClr val="17202A"/>
-                </a:solidFill>
-              </a:rPr>
-              <a:t>Macro F1: 0,965034</a:t>
-            </a:r>
-          </a:p>
-          <a:p xmlns:a="http://schemas.openxmlformats.org/drawingml/2006/main">
-            <a:pPr>
-              <a:defRPr sz="1575" b="0">
-                <a:solidFill>
-                  <a:srgbClr val="17202A"/>
-                </a:solidFill>
-              </a:defRPr>
-            </a:pPr>
-            <a:r>
-              <a:rPr sz="1575" b="0">
-                <a:solidFill>
-                  <a:srgbClr val="17202A"/>
-                </a:solidFill>
-              </a:rPr>
-              <a:t>389.924 tham số · train 1.118,7 giây</a:t>
-            </a:r>
-          </a:p>
-        </p:txBody>
-      </p:sp>
-      <p:sp>
-        <p:nvSpPr>
-          <p:cNvPr id="7" name="">
-            <a:extLst xmlns:a="http://schemas.openxmlformats.org/drawingml/2006/main">
-              <a:ext uri="{FF2B5EF4-FFF2-40B4-BE49-F238E27FC236}">
-                <a16:creationId xmlns:a16="http://schemas.microsoft.com/office/drawing/2014/main" id="{F376065A-7E0F-4460-89A4-51830652B4AD}"/>
-              </a:ext>
-            </a:extLst>
-          </p:cNvPr>
-          <p:cNvSpPr>
-            <a:spLocks xmlns:a="http://schemas.openxmlformats.org/drawingml/2006/main" noGrp="1"/>
-          </p:cNvSpPr>
-          <p:nvPr/>
-        </p:nvSpPr>
-        <p:spPr>
-          <a:xfrm xmlns:a="http://schemas.openxmlformats.org/drawingml/2006/main">
-            <a:off x="6191250" y="2857500"/>
-            <a:ext cx="2857500" cy="361950"/>
-          </a:xfrm>
-          <a:prstGeom xmlns:a="http://schemas.openxmlformats.org/drawingml/2006/main" prst="rect">
-            <a:avLst/>
-          </a:prstGeom>
-          <a:noFill xmlns:a="http://schemas.openxmlformats.org/drawingml/2006/main"/>
-          <a:ln xmlns:a="http://schemas.openxmlformats.org/drawingml/2006/main" w="0">
-            <a:noFill/>
-            <a:prstDash val="solid"/>
-          </a:ln>
-        </p:spPr>
-        <p:txBody>
-          <a:bodyPr xmlns:a="http://schemas.openxmlformats.org/drawingml/2006/main"/>
-          <a:lstStyle xmlns:a="http://schemas.openxmlformats.org/drawingml/2006/main">
-            <a:defPPr>
-              <a:defRPr sz="1800" b="1">
-                <a:solidFill>
-                  <a:srgbClr val="2F5597"/>
-                </a:solidFill>
-              </a:defRPr>
-            </a:defPPr>
-            <a:lvl1pPr>
-              <a:defRPr sz="1800" b="1">
-                <a:solidFill>
-                  <a:srgbClr val="2F5597"/>
-                </a:solidFill>
-              </a:defRPr>
-            </a:lvl1pPr>
-            <a:lvl2pPr>
-              <a:defRPr sz="1800" b="1">
-                <a:solidFill>
-                  <a:srgbClr val="2F5597"/>
-                </a:solidFill>
-              </a:defRPr>
-            </a:lvl2pPr>
-            <a:lvl3pPr>
-              <a:defRPr sz="1800" b="1">
-                <a:solidFill>
-                  <a:srgbClr val="2F5597"/>
-                </a:solidFill>
-              </a:defRPr>
-            </a:lvl3pPr>
-            <a:lvl4pPr>
-              <a:defRPr sz="1800" b="1">
-                <a:solidFill>
-                  <a:srgbClr val="2F5597"/>
-                </a:solidFill>
-              </a:defRPr>
-            </a:lvl4pPr>
-            <a:lvl5pPr>
-              <a:defRPr sz="1800" b="1">
-                <a:solidFill>
-                  <a:srgbClr val="2F5597"/>
-                </a:solidFill>
-              </a:defRPr>
-            </a:lvl5pPr>
-            <a:lvl6pPr>
-              <a:defRPr sz="1800" b="1">
-                <a:solidFill>
-                  <a:srgbClr val="2F5597"/>
-                </a:solidFill>
-              </a:defRPr>
-            </a:lvl6pPr>
-            <a:lvl7pPr>
-              <a:defRPr sz="1800" b="1">
-                <a:solidFill>
-                  <a:srgbClr val="2F5597"/>
-                </a:solidFill>
-              </a:defRPr>
-            </a:lvl7pPr>
-            <a:lvl8pPr>
-              <a:defRPr sz="1800" b="1">
-                <a:solidFill>
-                  <a:srgbClr val="2F5597"/>
-                </a:solidFill>
-              </a:defRPr>
-            </a:lvl8pPr>
-            <a:lvl9pPr>
-              <a:defRPr sz="1800" b="1">
-                <a:solidFill>
-                  <a:srgbClr val="2F5597"/>
-                </a:solidFill>
-              </a:defRPr>
-            </a:lvl9pPr>
-          </a:lstStyle>
-          <a:p xmlns:a="http://schemas.openxmlformats.org/drawingml/2006/main">
-            <a:pPr>
-              <a:defRPr sz="1800" b="1">
-                <a:solidFill>
-                  <a:srgbClr val="2F5597"/>
-                </a:solidFill>
-              </a:defRPr>
-            </a:pPr>
-            <a:r>
-              <a:rPr sz="1800" b="1">
-                <a:solidFill>
-                  <a:srgbClr val="2F5597"/>
-                </a:solidFill>
-              </a:rPr>
-              <a:t>ResNet18</a:t>
-            </a:r>
-          </a:p>
-        </p:txBody>
-      </p:sp>
-      <p:sp>
-        <p:nvSpPr>
-          <p:cNvPr id="8" name="">
-            <a:extLst xmlns:a="http://schemas.openxmlformats.org/drawingml/2006/main">
-              <a:ext uri="{FF2B5EF4-FFF2-40B4-BE49-F238E27FC236}">
-                <a16:creationId xmlns:a16="http://schemas.microsoft.com/office/drawing/2014/main" id="{F5413E3E-EB11-4740-9BCE-441BE50F04AD}"/>
-              </a:ext>
-            </a:extLst>
-          </p:cNvPr>
-          <p:cNvSpPr>
-            <a:spLocks xmlns:a="http://schemas.openxmlformats.org/drawingml/2006/main" noGrp="1"/>
-          </p:cNvSpPr>
-          <p:nvPr/>
-        </p:nvSpPr>
-        <p:spPr>
-          <a:xfrm xmlns:a="http://schemas.openxmlformats.org/drawingml/2006/main">
-            <a:off x="6191250" y="3333750"/>
-            <a:ext cx="4476750" cy="1238250"/>
-          </a:xfrm>
-          <a:prstGeom xmlns:a="http://schemas.openxmlformats.org/drawingml/2006/main" prst="rect">
-            <a:avLst/>
-          </a:prstGeom>
-          <a:noFill xmlns:a="http://schemas.openxmlformats.org/drawingml/2006/main"/>
-          <a:ln xmlns:a="http://schemas.openxmlformats.org/drawingml/2006/main" w="0">
-            <a:noFill/>
-            <a:prstDash val="solid"/>
-          </a:ln>
-        </p:spPr>
-        <p:txBody>
-          <a:bodyPr xmlns:a="http://schemas.openxmlformats.org/drawingml/2006/main"/>
-          <a:lstStyle xmlns:a="http://schemas.openxmlformats.org/drawingml/2006/main">
-            <a:defPPr>
-              <a:defRPr sz="1575" b="0">
-                <a:solidFill>
-                  <a:srgbClr val="17202A"/>
-                </a:solidFill>
-              </a:defRPr>
-            </a:defPPr>
-            <a:lvl1pPr>
-              <a:defRPr sz="1575" b="0">
-                <a:solidFill>
-                  <a:srgbClr val="17202A"/>
-                </a:solidFill>
-              </a:defRPr>
-            </a:lvl1pPr>
-            <a:lvl2pPr>
-              <a:defRPr sz="1575" b="0">
-                <a:solidFill>
-                  <a:srgbClr val="17202A"/>
-                </a:solidFill>
-              </a:defRPr>
-            </a:lvl2pPr>
-            <a:lvl3pPr>
-              <a:defRPr sz="1575" b="0">
-                <a:solidFill>
-                  <a:srgbClr val="17202A"/>
-                </a:solidFill>
-              </a:defRPr>
-            </a:lvl3pPr>
-            <a:lvl4pPr>
-              <a:defRPr sz="1575" b="0">
-                <a:solidFill>
-                  <a:srgbClr val="17202A"/>
-                </a:solidFill>
-              </a:defRPr>
-            </a:lvl4pPr>
-            <a:lvl5pPr>
-              <a:defRPr sz="1575" b="0">
-                <a:solidFill>
-                  <a:srgbClr val="17202A"/>
-                </a:solidFill>
-              </a:defRPr>
-            </a:lvl5pPr>
-            <a:lvl6pPr>
-              <a:defRPr sz="1575" b="0">
-                <a:solidFill>
-                  <a:srgbClr val="17202A"/>
-                </a:solidFill>
-              </a:defRPr>
-            </a:lvl6pPr>
-            <a:lvl7pPr>
-              <a:defRPr sz="1575" b="0">
-                <a:solidFill>
-                  <a:srgbClr val="17202A"/>
-                </a:solidFill>
-              </a:defRPr>
-            </a:lvl7pPr>
-            <a:lvl8pPr>
-              <a:defRPr sz="1575" b="0">
-                <a:solidFill>
-                  <a:srgbClr val="17202A"/>
-                </a:solidFill>
-              </a:defRPr>
-            </a:lvl8pPr>
-            <a:lvl9pPr>
-              <a:defRPr sz="1575" b="0">
-                <a:solidFill>
-                  <a:srgbClr val="17202A"/>
-                </a:solidFill>
-              </a:defRPr>
-            </a:lvl9pPr>
-          </a:lstStyle>
-          <a:p xmlns:a="http://schemas.openxmlformats.org/drawingml/2006/main">
-            <a:pPr>
-              <a:defRPr sz="1575" b="0">
-                <a:solidFill>
-                  <a:srgbClr val="17202A"/>
-                </a:solidFill>
-              </a:defRPr>
-            </a:pPr>
-            <a:r>
-              <a:rPr sz="1575" b="0">
-                <a:solidFill>
-                  <a:srgbClr val="17202A"/>
-                </a:solidFill>
-              </a:rPr>
-              <a:t>Accuracy: 0,986726</a:t>
-            </a:r>
-          </a:p>
-          <a:p xmlns:a="http://schemas.openxmlformats.org/drawingml/2006/main">
-            <a:pPr>
-              <a:defRPr sz="1575" b="0">
-                <a:solidFill>
-                  <a:srgbClr val="17202A"/>
-                </a:solidFill>
-              </a:defRPr>
-            </a:pPr>
-            <a:r>
-              <a:rPr sz="1575" b="0">
-                <a:solidFill>
-                  <a:srgbClr val="17202A"/>
-                </a:solidFill>
-              </a:rPr>
-              <a:t>Macro F1: 0,983978</a:t>
-            </a:r>
-          </a:p>
-          <a:p xmlns:a="http://schemas.openxmlformats.org/drawingml/2006/main">
-            <a:pPr>
-              <a:defRPr sz="1575" b="0">
-                <a:solidFill>
-                  <a:srgbClr val="17202A"/>
-                </a:solidFill>
-              </a:defRPr>
-            </a:pPr>
-            <a:r>
-              <a:rPr sz="1575" b="0">
-                <a:solidFill>
-                  <a:srgbClr val="17202A"/>
-                </a:solidFill>
-              </a:rPr>
-              <a:t>11.178.564 tham số · 8.395.780 trainable</a:t>
-            </a:r>
-          </a:p>
-        </p:txBody>
-      </p:sp>
+        </p:nvGraphicFramePr>
+        <p:xfrm>
+          <a:off xmlns:a="http://schemas.openxmlformats.org/drawingml/2006/main" x="2476500" y="3952875"/>
+          <a:ext xmlns:a="http://schemas.openxmlformats.org/drawingml/2006/main" cx="7239000" cy="1952625"/>
+        </p:xfrm>
+        <a:graphic xmlns:a="http://schemas.openxmlformats.org/drawingml/2006/main">
+          <a:graphicData uri="http://schemas.openxmlformats.org/drawingml/2006/chart">
+            <c:chart xmlns:r="http://schemas.openxmlformats.org/officeDocument/2006/relationships" xmlns:c="http://schemas.openxmlformats.org/drawingml/2006/chart" r:id="R0244d44063d645b1"/>
+          </a:graphicData>
+        </a:graphic>
+      </p:graphicFrame>
     </p:spTree>
     <p:extLst>
       <p:ext uri="{BB962C8B-B14F-4D97-AF65-F5344CB8AC3E}">
-        <p14:creationId xmlns:p14="http://schemas.microsoft.com/office/powerpoint/2010/main" val="881484496"/>
+        <p14:creationId xmlns:p14="http://schemas.microsoft.com/office/powerpoint/2010/main" val="486174730"/>
       </p:ext>
     </p:extLst>
   </p:cSld>
@@ -13033,7 +13283,7 @@
           <p:cNvPr id="8" name="">
             <a:extLst xmlns:a="http://schemas.openxmlformats.org/drawingml/2006/main">
               <a:ext uri="{FF2B5EF4-FFF2-40B4-BE49-F238E27FC236}">
-                <a16:creationId xmlns:a16="http://schemas.microsoft.com/office/drawing/2014/main" id="{EAEF020B-E596-4BD1-AE00-408A0E8D9D89}"/>
+                <a16:creationId xmlns:a16="http://schemas.microsoft.com/office/drawing/2014/main" id="{DC58ECE1-A402-4045-A7BC-1F79D4786620}"/>
               </a:ext>
             </a:extLst>
           </p:cNvPr>
@@ -13154,7 +13404,7 @@
           <p:cNvPr id="2" name="">
             <a:extLst xmlns:a="http://schemas.openxmlformats.org/drawingml/2006/main">
               <a:ext uri="{FF2B5EF4-FFF2-40B4-BE49-F238E27FC236}">
-                <a16:creationId xmlns:a16="http://schemas.microsoft.com/office/drawing/2014/main" id="{88574DF2-229E-4BF4-8E5F-FDA7AF5B2D36}"/>
+                <a16:creationId xmlns:a16="http://schemas.microsoft.com/office/drawing/2014/main" id="{20885138-C906-4811-8C75-E327A7D9FECF}"/>
               </a:ext>
             </a:extLst>
           </p:cNvPr>
@@ -13275,7 +13525,7 @@
           <p:cNvPr id="3" name="">
             <a:extLst xmlns:a="http://schemas.openxmlformats.org/drawingml/2006/main">
               <a:ext uri="{FF2B5EF4-FFF2-40B4-BE49-F238E27FC236}">
-                <a16:creationId xmlns:a16="http://schemas.microsoft.com/office/drawing/2014/main" id="{68843C73-038C-40BB-A6F6-8FD0171C59B4}"/>
+                <a16:creationId xmlns:a16="http://schemas.microsoft.com/office/drawing/2014/main" id="{FE058238-C19D-4A8E-9EF8-9A9841AFE422}"/>
               </a:ext>
             </a:extLst>
           </p:cNvPr>
@@ -13396,7 +13646,7 @@
           <p:cNvPr id="4" name="">
             <a:extLst xmlns:a="http://schemas.openxmlformats.org/drawingml/2006/main">
               <a:ext uri="{FF2B5EF4-FFF2-40B4-BE49-F238E27FC236}">
-                <a16:creationId xmlns:a16="http://schemas.microsoft.com/office/drawing/2014/main" id="{7CE8661A-2BD4-4F62-BFC0-46892C7E5ED1}"/>
+                <a16:creationId xmlns:a16="http://schemas.microsoft.com/office/drawing/2014/main" id="{86EAF9A8-9EE9-49F8-AD91-54B79C5D19C8}"/>
               </a:ext>
             </a:extLst>
           </p:cNvPr>
@@ -13585,7 +13835,7 @@
           <p:cNvPr id="5" name="">
             <a:extLst xmlns:a="http://schemas.openxmlformats.org/drawingml/2006/main">
               <a:ext uri="{FF2B5EF4-FFF2-40B4-BE49-F238E27FC236}">
-                <a16:creationId xmlns:a16="http://schemas.microsoft.com/office/drawing/2014/main" id="{F113D991-4B20-4720-948E-29F77B1DD0BF}"/>
+                <a16:creationId xmlns:a16="http://schemas.microsoft.com/office/drawing/2014/main" id="{5BCD2BDB-584F-4BB2-9510-BB455E8E81E6}"/>
               </a:ext>
             </a:extLst>
           </p:cNvPr>
@@ -13774,7 +14024,7 @@
           <p:cNvPr id="6" name="">
             <a:extLst xmlns:a="http://schemas.openxmlformats.org/drawingml/2006/main">
               <a:ext uri="{FF2B5EF4-FFF2-40B4-BE49-F238E27FC236}">
-                <a16:creationId xmlns:a16="http://schemas.microsoft.com/office/drawing/2014/main" id="{75B910E6-4477-4259-80A1-6F7388E93C0A}"/>
+                <a16:creationId xmlns:a16="http://schemas.microsoft.com/office/drawing/2014/main" id="{5E01A2C4-D360-4B39-8E0E-ACC1B4648FCC}"/>
               </a:ext>
             </a:extLst>
           </p:cNvPr>
@@ -13895,7 +14145,7 @@
           <p:cNvPr id="7" name="">
             <a:extLst xmlns:a="http://schemas.openxmlformats.org/drawingml/2006/main">
               <a:ext uri="{FF2B5EF4-FFF2-40B4-BE49-F238E27FC236}">
-                <a16:creationId xmlns:a16="http://schemas.microsoft.com/office/drawing/2014/main" id="{690EBD1F-8DAD-477B-A506-4C29C3B3AB31}"/>
+                <a16:creationId xmlns:a16="http://schemas.microsoft.com/office/drawing/2014/main" id="{6E60CC50-3559-4E1B-9482-7A1993E63151}"/>
               </a:ext>
             </a:extLst>
           </p:cNvPr>
@@ -14014,7 +14264,7 @@
     </p:spTree>
     <p:extLst>
       <p:ext uri="{BB962C8B-B14F-4D97-AF65-F5344CB8AC3E}">
-        <p14:creationId xmlns:p14="http://schemas.microsoft.com/office/powerpoint/2010/main" val="1598534952"/>
+        <p14:creationId xmlns:p14="http://schemas.microsoft.com/office/powerpoint/2010/main" val="1119377511"/>
       </p:ext>
     </p:extLst>
   </p:cSld>
@@ -14045,7 +14295,7 @@
           <p:cNvPr id="8" name="">
             <a:extLst xmlns:a="http://schemas.openxmlformats.org/drawingml/2006/main">
               <a:ext uri="{FF2B5EF4-FFF2-40B4-BE49-F238E27FC236}">
-                <a16:creationId xmlns:a16="http://schemas.microsoft.com/office/drawing/2014/main" id="{9FFD6C57-008D-4DFF-BE56-A964BA2C5114}"/>
+                <a16:creationId xmlns:a16="http://schemas.microsoft.com/office/drawing/2014/main" id="{E9586E60-38AC-4D78-A45C-164948B64106}"/>
               </a:ext>
             </a:extLst>
           </p:cNvPr>
@@ -14166,7 +14416,7 @@
           <p:cNvPr id="2" name="">
             <a:extLst xmlns:a="http://schemas.openxmlformats.org/drawingml/2006/main">
               <a:ext uri="{FF2B5EF4-FFF2-40B4-BE49-F238E27FC236}">
-                <a16:creationId xmlns:a16="http://schemas.microsoft.com/office/drawing/2014/main" id="{30BE3656-2BC0-4677-BC8D-30BC679C5D20}"/>
+                <a16:creationId xmlns:a16="http://schemas.microsoft.com/office/drawing/2014/main" id="{DA0F725F-73C8-4814-BE2E-671CA27A8B16}"/>
               </a:ext>
             </a:extLst>
           </p:cNvPr>
@@ -14277,7 +14527,7 @@
                   <a:srgbClr val="1F4E79"/>
                 </a:solidFill>
               </a:rPr>
-              <a:t>Demo và giới hạn</a:t>
+              <a:t>Demo Streamlit với hai checkpoint thật</a:t>
             </a:r>
           </a:p>
         </p:txBody>
@@ -14287,7 +14537,7 @@
           <p:cNvPr id="3" name="">
             <a:extLst xmlns:a="http://schemas.openxmlformats.org/drawingml/2006/main">
               <a:ext uri="{FF2B5EF4-FFF2-40B4-BE49-F238E27FC236}">
-                <a16:creationId xmlns:a16="http://schemas.microsoft.com/office/drawing/2014/main" id="{1D570B0B-470A-4D7E-9AE9-314862242D96}"/>
+                <a16:creationId xmlns:a16="http://schemas.microsoft.com/office/drawing/2014/main" id="{82765168-2218-4BAE-9566-CA44217CA181}"/>
               </a:ext>
             </a:extLst>
           </p:cNvPr>
@@ -14403,12 +14653,40 @@
           </a:p>
         </p:txBody>
       </p:sp>
-      <p:sp>
-        <p:nvSpPr>
+      <p:pic>
+        <p:nvPicPr>
           <p:cNvPr id="4" name="">
             <a:extLst xmlns:a="http://schemas.openxmlformats.org/drawingml/2006/main">
               <a:ext uri="{FF2B5EF4-FFF2-40B4-BE49-F238E27FC236}">
-                <a16:creationId xmlns:a16="http://schemas.microsoft.com/office/drawing/2014/main" id="{1172DA98-2D42-47C2-A896-8E1A299C8518}"/>
+                <a16:creationId xmlns:a16="http://schemas.microsoft.com/office/drawing/2014/main" id="{64F42D35-7975-4D1F-BBF8-8709ECE49F62}"/>
+              </a:ext>
+            </a:extLst>
+          </p:cNvPr>
+          <p:cNvPicPr>
+            <a:picLocks xmlns:a="http://schemas.openxmlformats.org/drawingml/2006/main" noChangeAspect="1"/>
+          </p:cNvPicPr>
+          <p:nvPr/>
+        </p:nvPicPr>
+        <p:blipFill>
+          <a:blip xmlns:r="http://schemas.openxmlformats.org/officeDocument/2006/relationships" xmlns:a="http://schemas.openxmlformats.org/drawingml/2006/main" r:embed="R11897588ded5406d"/>
+          <a:stretch xmlns:a="http://schemas.openxmlformats.org/drawingml/2006/main"/>
+        </p:blipFill>
+        <p:spPr>
+          <a:xfrm xmlns:a="http://schemas.openxmlformats.org/drawingml/2006/main">
+            <a:off x="819150" y="1580555"/>
+            <a:ext cx="6572250" cy="3696891"/>
+          </a:xfrm>
+          <a:prstGeom xmlns:a="http://schemas.openxmlformats.org/drawingml/2006/main" prst="rect">
+            <a:avLst/>
+          </a:prstGeom>
+        </p:spPr>
+      </p:pic>
+      <p:sp>
+        <p:nvSpPr>
+          <p:cNvPr id="5" name="">
+            <a:extLst xmlns:a="http://schemas.openxmlformats.org/drawingml/2006/main">
+              <a:ext uri="{FF2B5EF4-FFF2-40B4-BE49-F238E27FC236}">
+                <a16:creationId xmlns:a16="http://schemas.microsoft.com/office/drawing/2014/main" id="{FDE27D46-2ABF-4459-AE98-895192CE7667}"/>
               </a:ext>
             </a:extLst>
           </p:cNvPr>
@@ -14419,8 +14697,8 @@
         </p:nvSpPr>
         <p:spPr>
           <a:xfrm xmlns:a="http://schemas.openxmlformats.org/drawingml/2006/main">
-            <a:off x="819150" y="1762125"/>
-            <a:ext cx="2667000" cy="304800"/>
+            <a:off x="7858125" y="1714500"/>
+            <a:ext cx="3143250" cy="304800"/>
           </a:xfrm>
           <a:prstGeom xmlns:a="http://schemas.openxmlformats.org/drawingml/2006/main" prst="rect">
             <a:avLst/>
@@ -14435,70 +14713,70 @@
           <a:bodyPr xmlns:a="http://schemas.openxmlformats.org/drawingml/2006/main"/>
           <a:lstStyle xmlns:a="http://schemas.openxmlformats.org/drawingml/2006/main">
             <a:defPPr>
-              <a:defRPr sz="1875" b="1">
+              <a:defRPr sz="1725" b="1">
                 <a:solidFill>
                   <a:srgbClr val="2F5597"/>
                 </a:solidFill>
               </a:defRPr>
             </a:defPPr>
             <a:lvl1pPr>
-              <a:defRPr sz="1875" b="1">
+              <a:defRPr sz="1725" b="1">
                 <a:solidFill>
                   <a:srgbClr val="2F5597"/>
                 </a:solidFill>
               </a:defRPr>
             </a:lvl1pPr>
             <a:lvl2pPr>
-              <a:defRPr sz="1875" b="1">
+              <a:defRPr sz="1725" b="1">
                 <a:solidFill>
                   <a:srgbClr val="2F5597"/>
                 </a:solidFill>
               </a:defRPr>
             </a:lvl2pPr>
             <a:lvl3pPr>
-              <a:defRPr sz="1875" b="1">
+              <a:defRPr sz="1725" b="1">
                 <a:solidFill>
                   <a:srgbClr val="2F5597"/>
                 </a:solidFill>
               </a:defRPr>
             </a:lvl3pPr>
             <a:lvl4pPr>
-              <a:defRPr sz="1875" b="1">
+              <a:defRPr sz="1725" b="1">
                 <a:solidFill>
                   <a:srgbClr val="2F5597"/>
                 </a:solidFill>
               </a:defRPr>
             </a:lvl4pPr>
             <a:lvl5pPr>
-              <a:defRPr sz="1875" b="1">
+              <a:defRPr sz="1725" b="1">
                 <a:solidFill>
                   <a:srgbClr val="2F5597"/>
                 </a:solidFill>
               </a:defRPr>
             </a:lvl5pPr>
             <a:lvl6pPr>
-              <a:defRPr sz="1875" b="1">
+              <a:defRPr sz="1725" b="1">
                 <a:solidFill>
                   <a:srgbClr val="2F5597"/>
                 </a:solidFill>
               </a:defRPr>
             </a:lvl6pPr>
             <a:lvl7pPr>
-              <a:defRPr sz="1875" b="1">
+              <a:defRPr sz="1725" b="1">
                 <a:solidFill>
                   <a:srgbClr val="2F5597"/>
                 </a:solidFill>
               </a:defRPr>
             </a:lvl7pPr>
             <a:lvl8pPr>
-              <a:defRPr sz="1875" b="1">
+              <a:defRPr sz="1725" b="1">
                 <a:solidFill>
                   <a:srgbClr val="2F5597"/>
                 </a:solidFill>
               </a:defRPr>
             </a:lvl8pPr>
             <a:lvl9pPr>
-              <a:defRPr sz="1875" b="1">
+              <a:defRPr sz="1725" b="1">
                 <a:solidFill>
                   <a:srgbClr val="2F5597"/>
                 </a:solidFill>
@@ -14507,29 +14785,29 @@
           </a:lstStyle>
           <a:p xmlns:a="http://schemas.openxmlformats.org/drawingml/2006/main">
             <a:pPr>
-              <a:defRPr sz="1875" b="1">
+              <a:defRPr sz="1725" b="1">
                 <a:solidFill>
                   <a:srgbClr val="2F5597"/>
                 </a:solidFill>
               </a:defRPr>
             </a:pPr>
             <a:r>
-              <a:rPr sz="1875" b="1">
+              <a:rPr sz="1725" b="1">
                 <a:solidFill>
                   <a:srgbClr val="2F5597"/>
                 </a:solidFill>
               </a:rPr>
-              <a:t>Demo</a:t>
+              <a:t>Kết quả trên một ảnh Test</a:t>
             </a:r>
           </a:p>
         </p:txBody>
       </p:sp>
       <p:sp>
         <p:nvSpPr>
-          <p:cNvPr id="5" name="">
+          <p:cNvPr id="6" name="">
             <a:extLst xmlns:a="http://schemas.openxmlformats.org/drawingml/2006/main">
               <a:ext uri="{FF2B5EF4-FFF2-40B4-BE49-F238E27FC236}">
-                <a16:creationId xmlns:a16="http://schemas.microsoft.com/office/drawing/2014/main" id="{50CF44F2-F7B7-4CF0-A7A2-D0F568D1F71C}"/>
+                <a16:creationId xmlns:a16="http://schemas.microsoft.com/office/drawing/2014/main" id="{E163D79C-3135-446F-9B1B-3DD748077D3D}"/>
               </a:ext>
             </a:extLst>
           </p:cNvPr>
@@ -14540,8 +14818,8 @@
         </p:nvSpPr>
         <p:spPr>
           <a:xfrm xmlns:a="http://schemas.openxmlformats.org/drawingml/2006/main">
-            <a:off x="819150" y="2238375"/>
-            <a:ext cx="5048250" cy="1428750"/>
+            <a:off x="7858125" y="2190750"/>
+            <a:ext cx="3143250" cy="1714500"/>
           </a:xfrm>
           <a:prstGeom xmlns:a="http://schemas.openxmlformats.org/drawingml/2006/main" prst="rect">
             <a:avLst/>
@@ -14556,70 +14834,70 @@
           <a:bodyPr xmlns:a="http://schemas.openxmlformats.org/drawingml/2006/main"/>
           <a:lstStyle xmlns:a="http://schemas.openxmlformats.org/drawingml/2006/main">
             <a:defPPr>
-              <a:defRPr sz="1500" b="0">
+              <a:defRPr sz="1425" b="0">
                 <a:solidFill>
                   <a:srgbClr val="17202A"/>
                 </a:solidFill>
               </a:defRPr>
             </a:defPPr>
             <a:lvl1pPr>
-              <a:defRPr sz="1500" b="0">
+              <a:defRPr sz="1425" b="0">
                 <a:solidFill>
                   <a:srgbClr val="17202A"/>
                 </a:solidFill>
               </a:defRPr>
             </a:lvl1pPr>
             <a:lvl2pPr>
-              <a:defRPr sz="1500" b="0">
+              <a:defRPr sz="1425" b="0">
                 <a:solidFill>
                   <a:srgbClr val="17202A"/>
                 </a:solidFill>
               </a:defRPr>
             </a:lvl2pPr>
             <a:lvl3pPr>
-              <a:defRPr sz="1500" b="0">
+              <a:defRPr sz="1425" b="0">
                 <a:solidFill>
                   <a:srgbClr val="17202A"/>
                 </a:solidFill>
               </a:defRPr>
             </a:lvl3pPr>
             <a:lvl4pPr>
-              <a:defRPr sz="1500" b="0">
+              <a:defRPr sz="1425" b="0">
                 <a:solidFill>
                   <a:srgbClr val="17202A"/>
                 </a:solidFill>
               </a:defRPr>
             </a:lvl4pPr>
             <a:lvl5pPr>
-              <a:defRPr sz="1500" b="0">
+              <a:defRPr sz="1425" b="0">
                 <a:solidFill>
                   <a:srgbClr val="17202A"/>
                 </a:solidFill>
               </a:defRPr>
             </a:lvl5pPr>
             <a:lvl6pPr>
-              <a:defRPr sz="1500" b="0">
+              <a:defRPr sz="1425" b="0">
                 <a:solidFill>
                   <a:srgbClr val="17202A"/>
                 </a:solidFill>
               </a:defRPr>
             </a:lvl6pPr>
             <a:lvl7pPr>
-              <a:defRPr sz="1500" b="0">
+              <a:defRPr sz="1425" b="0">
                 <a:solidFill>
                   <a:srgbClr val="17202A"/>
                 </a:solidFill>
               </a:defRPr>
             </a:lvl7pPr>
             <a:lvl8pPr>
-              <a:defRPr sz="1500" b="0">
+              <a:defRPr sz="1425" b="0">
                 <a:solidFill>
                   <a:srgbClr val="17202A"/>
                 </a:solidFill>
               </a:defRPr>
             </a:lvl8pPr>
             <a:lvl9pPr>
-              <a:defRPr sz="1500" b="0">
+              <a:defRPr sz="1425" b="0">
                 <a:solidFill>
                   <a:srgbClr val="17202A"/>
                 </a:solidFill>
@@ -14628,63 +14906,80 @@
           </a:lstStyle>
           <a:p xmlns:a="http://schemas.openxmlformats.org/drawingml/2006/main">
             <a:pPr>
-              <a:defRPr sz="1500" b="0">
+              <a:defRPr sz="1425" b="0">
                 <a:solidFill>
                   <a:srgbClr val="17202A"/>
                 </a:solidFill>
               </a:defRPr>
             </a:pPr>
             <a:r>
-              <a:rPr sz="1500" b="0">
+              <a:rPr sz="1425" b="0">
                 <a:solidFill>
                   <a:srgbClr val="17202A"/>
                 </a:solidFill>
               </a:rPr>
-              <a:t>Streamlit: upload, CNN, ResNet18, so sánh</a:t>
+              <a:t>CNN: Bacterial Spot 96,95%</a:t>
             </a:r>
           </a:p>
           <a:p xmlns:a="http://schemas.openxmlformats.org/drawingml/2006/main">
             <a:pPr>
-              <a:defRPr sz="1500" b="0">
+              <a:defRPr sz="1425" b="0">
                 <a:solidFill>
                   <a:srgbClr val="17202A"/>
                 </a:solidFill>
               </a:defRPr>
             </a:pPr>
             <a:r>
-              <a:rPr sz="1500" b="0">
+              <a:rPr sz="1425" b="0">
                 <a:solidFill>
                   <a:srgbClr val="17202A"/>
                 </a:solidFill>
               </a:rPr>
-              <a:t>Cả hai strict-load CPU; --model both: max |delta| = 0</a:t>
+              <a:t>ResNet18: Bacterial Spot 67,11%</a:t>
             </a:r>
           </a:p>
           <a:p xmlns:a="http://schemas.openxmlformats.org/drawingml/2006/main">
             <a:pPr>
-              <a:defRPr sz="1500" b="0">
+              <a:defRPr sz="1425" b="0">
                 <a:solidFill>
                   <a:srgbClr val="17202A"/>
                 </a:solidFill>
               </a:defRPr>
             </a:pPr>
             <a:r>
-              <a:rPr sz="1500" b="0">
+              <a:rPr sz="1425" b="0">
                 <a:solidFill>
                   <a:srgbClr val="17202A"/>
                 </a:solidFill>
               </a:rPr>
-              <a:t>Ảnh/video cuối: chờ NV4 xác nhận</a:t>
+              <a:t>Cả hai strict-load CPU</a:t>
+            </a:r>
+          </a:p>
+          <a:p xmlns:a="http://schemas.openxmlformats.org/drawingml/2006/main">
+            <a:pPr>
+              <a:defRPr sz="1425" b="0">
+                <a:solidFill>
+                  <a:srgbClr val="17202A"/>
+                </a:solidFill>
+              </a:defRPr>
+            </a:pPr>
+            <a:r>
+              <a:rPr sz="1425" b="0">
+                <a:solidFill>
+                  <a:srgbClr val="17202A"/>
+                </a:solidFill>
+              </a:rPr>
+              <a:t>--model both: max |delta| = 0</a:t>
             </a:r>
           </a:p>
         </p:txBody>
       </p:sp>
       <p:sp>
         <p:nvSpPr>
-          <p:cNvPr id="6" name="">
+          <p:cNvPr id="7" name="">
             <a:extLst xmlns:a="http://schemas.openxmlformats.org/drawingml/2006/main">
               <a:ext uri="{FF2B5EF4-FFF2-40B4-BE49-F238E27FC236}">
-                <a16:creationId xmlns:a16="http://schemas.microsoft.com/office/drawing/2014/main" id="{4DA2526E-33A7-4B64-A466-4EC4766E3B04}"/>
+                <a16:creationId xmlns:a16="http://schemas.microsoft.com/office/drawing/2014/main" id="{2DCE7637-5CD7-4203-A35D-48E9774D4E6E}"/>
               </a:ext>
             </a:extLst>
           </p:cNvPr>
@@ -14695,8 +14990,8 @@
         </p:nvSpPr>
         <p:spPr>
           <a:xfrm xmlns:a="http://schemas.openxmlformats.org/drawingml/2006/main">
-            <a:off x="6667500" y="1762125"/>
-            <a:ext cx="2667000" cy="304800"/>
+            <a:off x="819150" y="5572125"/>
+            <a:ext cx="10191750" cy="428625"/>
           </a:xfrm>
           <a:prstGeom xmlns:a="http://schemas.openxmlformats.org/drawingml/2006/main" prst="rect">
             <a:avLst/>
@@ -14711,246 +15006,91 @@
           <a:bodyPr xmlns:a="http://schemas.openxmlformats.org/drawingml/2006/main"/>
           <a:lstStyle xmlns:a="http://schemas.openxmlformats.org/drawingml/2006/main">
             <a:defPPr>
-              <a:defRPr sz="1875" b="1">
-                <a:solidFill>
-                  <a:srgbClr val="2F5597"/>
+              <a:defRPr sz="1125" b="0">
+                <a:solidFill>
+                  <a:srgbClr val="5B6573"/>
                 </a:solidFill>
               </a:defRPr>
             </a:defPPr>
             <a:lvl1pPr>
-              <a:defRPr sz="1875" b="1">
-                <a:solidFill>
-                  <a:srgbClr val="2F5597"/>
+              <a:defRPr sz="1125" b="0">
+                <a:solidFill>
+                  <a:srgbClr val="5B6573"/>
                 </a:solidFill>
               </a:defRPr>
             </a:lvl1pPr>
             <a:lvl2pPr>
-              <a:defRPr sz="1875" b="1">
-                <a:solidFill>
-                  <a:srgbClr val="2F5597"/>
+              <a:defRPr sz="1125" b="0">
+                <a:solidFill>
+                  <a:srgbClr val="5B6573"/>
                 </a:solidFill>
               </a:defRPr>
             </a:lvl2pPr>
             <a:lvl3pPr>
-              <a:defRPr sz="1875" b="1">
-                <a:solidFill>
-                  <a:srgbClr val="2F5597"/>
+              <a:defRPr sz="1125" b="0">
+                <a:solidFill>
+                  <a:srgbClr val="5B6573"/>
                 </a:solidFill>
               </a:defRPr>
             </a:lvl3pPr>
             <a:lvl4pPr>
-              <a:defRPr sz="1875" b="1">
-                <a:solidFill>
-                  <a:srgbClr val="2F5597"/>
+              <a:defRPr sz="1125" b="0">
+                <a:solidFill>
+                  <a:srgbClr val="5B6573"/>
                 </a:solidFill>
               </a:defRPr>
             </a:lvl4pPr>
             <a:lvl5pPr>
-              <a:defRPr sz="1875" b="1">
-                <a:solidFill>
-                  <a:srgbClr val="2F5597"/>
+              <a:defRPr sz="1125" b="0">
+                <a:solidFill>
+                  <a:srgbClr val="5B6573"/>
                 </a:solidFill>
               </a:defRPr>
             </a:lvl5pPr>
             <a:lvl6pPr>
-              <a:defRPr sz="1875" b="1">
-                <a:solidFill>
-                  <a:srgbClr val="2F5597"/>
+              <a:defRPr sz="1125" b="0">
+                <a:solidFill>
+                  <a:srgbClr val="5B6573"/>
                 </a:solidFill>
               </a:defRPr>
             </a:lvl6pPr>
             <a:lvl7pPr>
-              <a:defRPr sz="1875" b="1">
-                <a:solidFill>
-                  <a:srgbClr val="2F5597"/>
+              <a:defRPr sz="1125" b="0">
+                <a:solidFill>
+                  <a:srgbClr val="5B6573"/>
                 </a:solidFill>
               </a:defRPr>
             </a:lvl7pPr>
             <a:lvl8pPr>
-              <a:defRPr sz="1875" b="1">
-                <a:solidFill>
-                  <a:srgbClr val="2F5597"/>
+              <a:defRPr sz="1125" b="0">
+                <a:solidFill>
+                  <a:srgbClr val="5B6573"/>
                 </a:solidFill>
               </a:defRPr>
             </a:lvl8pPr>
             <a:lvl9pPr>
-              <a:defRPr sz="1875" b="1">
-                <a:solidFill>
-                  <a:srgbClr val="2F5597"/>
+              <a:defRPr sz="1125" b="0">
+                <a:solidFill>
+                  <a:srgbClr val="5B6573"/>
                 </a:solidFill>
               </a:defRPr>
             </a:lvl9pPr>
           </a:lstStyle>
           <a:p xmlns:a="http://schemas.openxmlformats.org/drawingml/2006/main">
             <a:pPr>
-              <a:defRPr sz="1875" b="1">
-                <a:solidFill>
-                  <a:srgbClr val="2F5597"/>
+              <a:defRPr sz="1125" b="0">
+                <a:solidFill>
+                  <a:srgbClr val="5B6573"/>
                 </a:solidFill>
               </a:defRPr>
             </a:pPr>
             <a:r>
-              <a:rPr sz="1875" b="1">
-                <a:solidFill>
-                  <a:srgbClr val="2F5597"/>
+              <a:rPr sz="1125" b="0">
+                <a:solidFill>
+                  <a:srgbClr val="5B6573"/>
                 </a:solidFill>
               </a:rPr>
-              <a:t>Giới hạn</a:t>
-            </a:r>
-          </a:p>
-        </p:txBody>
-      </p:sp>
-      <p:sp>
-        <p:nvSpPr>
-          <p:cNvPr id="7" name="">
-            <a:extLst xmlns:a="http://schemas.openxmlformats.org/drawingml/2006/main">
-              <a:ext uri="{FF2B5EF4-FFF2-40B4-BE49-F238E27FC236}">
-                <a16:creationId xmlns:a16="http://schemas.microsoft.com/office/drawing/2014/main" id="{F77CE271-E897-455D-934A-62C3476108FB}"/>
-              </a:ext>
-            </a:extLst>
-          </p:cNvPr>
-          <p:cNvSpPr>
-            <a:spLocks xmlns:a="http://schemas.openxmlformats.org/drawingml/2006/main" noGrp="1"/>
-          </p:cNvSpPr>
-          <p:nvPr/>
-        </p:nvSpPr>
-        <p:spPr>
-          <a:xfrm xmlns:a="http://schemas.openxmlformats.org/drawingml/2006/main">
-            <a:off x="6667500" y="2238375"/>
-            <a:ext cx="4000500" cy="1428750"/>
-          </a:xfrm>
-          <a:prstGeom xmlns:a="http://schemas.openxmlformats.org/drawingml/2006/main" prst="rect">
-            <a:avLst/>
-          </a:prstGeom>
-          <a:noFill xmlns:a="http://schemas.openxmlformats.org/drawingml/2006/main"/>
-          <a:ln xmlns:a="http://schemas.openxmlformats.org/drawingml/2006/main" w="0">
-            <a:noFill/>
-            <a:prstDash val="solid"/>
-          </a:ln>
-        </p:spPr>
-        <p:txBody>
-          <a:bodyPr xmlns:a="http://schemas.openxmlformats.org/drawingml/2006/main"/>
-          <a:lstStyle xmlns:a="http://schemas.openxmlformats.org/drawingml/2006/main">
-            <a:defPPr>
-              <a:defRPr sz="1650" b="0">
-                <a:solidFill>
-                  <a:srgbClr val="17202A"/>
-                </a:solidFill>
-              </a:defRPr>
-            </a:defPPr>
-            <a:lvl1pPr>
-              <a:defRPr sz="1650" b="0">
-                <a:solidFill>
-                  <a:srgbClr val="17202A"/>
-                </a:solidFill>
-              </a:defRPr>
-            </a:lvl1pPr>
-            <a:lvl2pPr>
-              <a:defRPr sz="1650" b="0">
-                <a:solidFill>
-                  <a:srgbClr val="17202A"/>
-                </a:solidFill>
-              </a:defRPr>
-            </a:lvl2pPr>
-            <a:lvl3pPr>
-              <a:defRPr sz="1650" b="0">
-                <a:solidFill>
-                  <a:srgbClr val="17202A"/>
-                </a:solidFill>
-              </a:defRPr>
-            </a:lvl3pPr>
-            <a:lvl4pPr>
-              <a:defRPr sz="1650" b="0">
-                <a:solidFill>
-                  <a:srgbClr val="17202A"/>
-                </a:solidFill>
-              </a:defRPr>
-            </a:lvl4pPr>
-            <a:lvl5pPr>
-              <a:defRPr sz="1650" b="0">
-                <a:solidFill>
-                  <a:srgbClr val="17202A"/>
-                </a:solidFill>
-              </a:defRPr>
-            </a:lvl5pPr>
-            <a:lvl6pPr>
-              <a:defRPr sz="1650" b="0">
-                <a:solidFill>
-                  <a:srgbClr val="17202A"/>
-                </a:solidFill>
-              </a:defRPr>
-            </a:lvl6pPr>
-            <a:lvl7pPr>
-              <a:defRPr sz="1650" b="0">
-                <a:solidFill>
-                  <a:srgbClr val="17202A"/>
-                </a:solidFill>
-              </a:defRPr>
-            </a:lvl7pPr>
-            <a:lvl8pPr>
-              <a:defRPr sz="1650" b="0">
-                <a:solidFill>
-                  <a:srgbClr val="17202A"/>
-                </a:solidFill>
-              </a:defRPr>
-            </a:lvl8pPr>
-            <a:lvl9pPr>
-              <a:defRPr sz="1650" b="0">
-                <a:solidFill>
-                  <a:srgbClr val="17202A"/>
-                </a:solidFill>
-              </a:defRPr>
-            </a:lvl9pPr>
-          </a:lstStyle>
-          <a:p xmlns:a="http://schemas.openxmlformats.org/drawingml/2006/main">
-            <a:pPr>
-              <a:defRPr sz="1650" b="0">
-                <a:solidFill>
-                  <a:srgbClr val="17202A"/>
-                </a:solidFill>
-              </a:defRPr>
-            </a:pPr>
-            <a:r>
-              <a:rPr sz="1650" b="0">
-                <a:solidFill>
-                  <a:srgbClr val="17202A"/>
-                </a:solidFill>
-              </a:rPr>
-              <a:t>Không thay thế chuyên gia.</a:t>
-            </a:r>
-          </a:p>
-          <a:p xmlns:a="http://schemas.openxmlformats.org/drawingml/2006/main">
-            <a:pPr>
-              <a:defRPr sz="1650" b="0">
-                <a:solidFill>
-                  <a:srgbClr val="17202A"/>
-                </a:solidFill>
-              </a:defRPr>
-            </a:pPr>
-            <a:r>
-              <a:rPr sz="1650" b="0">
-                <a:solidFill>
-                  <a:srgbClr val="17202A"/>
-                </a:solidFill>
-              </a:rPr>
-              <a:t>Ảnh ngoài miền có thể bị ép vào một lớp.</a:t>
-            </a:r>
-          </a:p>
-          <a:p xmlns:a="http://schemas.openxmlformats.org/drawingml/2006/main">
-            <a:pPr>
-              <a:defRPr sz="1650" b="0">
-                <a:solidFill>
-                  <a:srgbClr val="17202A"/>
-                </a:solidFill>
-              </a:defRPr>
-            </a:pPr>
-            <a:r>
-              <a:rPr sz="1650" b="0">
-                <a:solidFill>
-                  <a:srgbClr val="17202A"/>
-                </a:solidFill>
-              </a:rPr>
-              <a:t>Chưa chứng minh phát hiện sớm.</a:t>
+              <a:t>Nguồn: ảnh chụp NV4, commit 2406b12. Đây là minh họa giao diện, không phải Accuracy toàn tập. Video chưa bàn giao.</a:t>
             </a:r>
           </a:p>
         </p:txBody>
@@ -14958,7 +15098,7 @@
     </p:spTree>
     <p:extLst>
       <p:ext uri="{BB962C8B-B14F-4D97-AF65-F5344CB8AC3E}">
-        <p14:creationId xmlns:p14="http://schemas.microsoft.com/office/powerpoint/2010/main" val="717556609"/>
+        <p14:creationId xmlns:p14="http://schemas.microsoft.com/office/powerpoint/2010/main" val="1933795161"/>
       </p:ext>
     </p:extLst>
   </p:cSld>
@@ -14989,7 +15129,7 @@
           <p:cNvPr id="9" name="">
             <a:extLst xmlns:a="http://schemas.openxmlformats.org/drawingml/2006/main">
               <a:ext uri="{FF2B5EF4-FFF2-40B4-BE49-F238E27FC236}">
-                <a16:creationId xmlns:a16="http://schemas.microsoft.com/office/drawing/2014/main" id="{684E6139-07F3-405B-87A4-81293C5357BF}"/>
+                <a16:creationId xmlns:a16="http://schemas.microsoft.com/office/drawing/2014/main" id="{4157B864-5ADB-4BA7-8BF0-6FB5F7123157}"/>
               </a:ext>
             </a:extLst>
           </p:cNvPr>
@@ -15110,7 +15250,7 @@
           <p:cNvPr id="2" name="">
             <a:extLst xmlns:a="http://schemas.openxmlformats.org/drawingml/2006/main">
               <a:ext uri="{FF2B5EF4-FFF2-40B4-BE49-F238E27FC236}">
-                <a16:creationId xmlns:a16="http://schemas.microsoft.com/office/drawing/2014/main" id="{06F1D652-70DF-46EF-95A1-7965EA17C1BB}"/>
+                <a16:creationId xmlns:a16="http://schemas.microsoft.com/office/drawing/2014/main" id="{9EEF3BDF-15F1-4EC3-AD6C-89EBCC7BC04F}"/>
               </a:ext>
             </a:extLst>
           </p:cNvPr>
@@ -15231,7 +15371,7 @@
           <p:cNvPr id="3" name="">
             <a:extLst xmlns:a="http://schemas.openxmlformats.org/drawingml/2006/main">
               <a:ext uri="{FF2B5EF4-FFF2-40B4-BE49-F238E27FC236}">
-                <a16:creationId xmlns:a16="http://schemas.microsoft.com/office/drawing/2014/main" id="{4F0C16E2-3788-4C2E-BDA5-65929FBFDB4F}"/>
+                <a16:creationId xmlns:a16="http://schemas.microsoft.com/office/drawing/2014/main" id="{0CBC657B-D263-4F7E-9B10-E46EEB4C0FA3}"/>
               </a:ext>
             </a:extLst>
           </p:cNvPr>
@@ -15352,7 +15492,7 @@
           <p:cNvPr id="4" name="">
             <a:extLst xmlns:a="http://schemas.openxmlformats.org/drawingml/2006/main">
               <a:ext uri="{FF2B5EF4-FFF2-40B4-BE49-F238E27FC236}">
-                <a16:creationId xmlns:a16="http://schemas.microsoft.com/office/drawing/2014/main" id="{0C8F66BD-D388-4EA8-A6B7-4DCB03FB1FC5}"/>
+                <a16:creationId xmlns:a16="http://schemas.microsoft.com/office/drawing/2014/main" id="{74DE58C8-F2D1-48B0-859A-6E9D573ED81C}"/>
               </a:ext>
             </a:extLst>
           </p:cNvPr>
@@ -15473,7 +15613,7 @@
           <p:cNvPr id="5" name="">
             <a:extLst xmlns:a="http://schemas.openxmlformats.org/drawingml/2006/main">
               <a:ext uri="{FF2B5EF4-FFF2-40B4-BE49-F238E27FC236}">
-                <a16:creationId xmlns:a16="http://schemas.microsoft.com/office/drawing/2014/main" id="{C9B763E4-C57A-412A-B441-7C8DE101D6D6}"/>
+                <a16:creationId xmlns:a16="http://schemas.microsoft.com/office/drawing/2014/main" id="{35E21C41-C80C-425A-9A9F-AAF232BF044F}"/>
               </a:ext>
             </a:extLst>
           </p:cNvPr>
@@ -15611,7 +15751,7 @@
           <p:cNvPr id="6" name="">
             <a:extLst xmlns:a="http://schemas.openxmlformats.org/drawingml/2006/main">
               <a:ext uri="{FF2B5EF4-FFF2-40B4-BE49-F238E27FC236}">
-                <a16:creationId xmlns:a16="http://schemas.microsoft.com/office/drawing/2014/main" id="{3BA52067-055B-4830-A912-9EA5C3E914D3}"/>
+                <a16:creationId xmlns:a16="http://schemas.microsoft.com/office/drawing/2014/main" id="{6E44AA35-245C-4117-9371-4BAAF5E200D0}"/>
               </a:ext>
             </a:extLst>
           </p:cNvPr>
@@ -15732,7 +15872,7 @@
           <p:cNvPr id="7" name="">
             <a:extLst xmlns:a="http://schemas.openxmlformats.org/drawingml/2006/main">
               <a:ext uri="{FF2B5EF4-FFF2-40B4-BE49-F238E27FC236}">
-                <a16:creationId xmlns:a16="http://schemas.microsoft.com/office/drawing/2014/main" id="{62E08EE6-457C-4CAF-AE44-86090E653413}"/>
+                <a16:creationId xmlns:a16="http://schemas.microsoft.com/office/drawing/2014/main" id="{B4D65B5A-2546-4055-80FA-9CE48E01D915}"/>
               </a:ext>
             </a:extLst>
           </p:cNvPr>
@@ -15887,7 +16027,7 @@
           <p:cNvPr id="8" name="">
             <a:extLst xmlns:a="http://schemas.openxmlformats.org/drawingml/2006/main">
               <a:ext uri="{FF2B5EF4-FFF2-40B4-BE49-F238E27FC236}">
-                <a16:creationId xmlns:a16="http://schemas.microsoft.com/office/drawing/2014/main" id="{3200DE21-34B7-4AFB-8215-0FF711B8D01E}"/>
+                <a16:creationId xmlns:a16="http://schemas.microsoft.com/office/drawing/2014/main" id="{35CE2806-A464-4A8E-8B64-52815E6FD10D}"/>
               </a:ext>
             </a:extLst>
           </p:cNvPr>
@@ -16006,7 +16146,7 @@
     </p:spTree>
     <p:extLst>
       <p:ext uri="{BB962C8B-B14F-4D97-AF65-F5344CB8AC3E}">
-        <p14:creationId xmlns:p14="http://schemas.microsoft.com/office/powerpoint/2010/main" val="250126326"/>
+        <p14:creationId xmlns:p14="http://schemas.microsoft.com/office/powerpoint/2010/main" val="1036176407"/>
       </p:ext>
     </p:extLst>
   </p:cSld>

</xml_diff>